<commit_message>
Paparan direksi template: hapus baris 'Paparan kepada Direksi' di sampul
Co-Authored-By: Claude Opus 5.5 <noreply@anthropic.com>
Claude-Session: https://claude.ai/code/session_01JEY5regGSA4jYBqyTUCMow
</commit_message>
<xml_diff>
--- a/docs/PID_POS_Paparan_Direksi_Template.pptx
+++ b/docs/PID_POS_Paparan_Direksi_Template.pptx
@@ -114,12 +114,12 @@
   <p:extLst>
     <p:ext uri="{521415D9-36F7-43E2-AB2F-B90AF26B5E84}">
       <p14:sectionLst xmlns:p14="http://schemas.microsoft.com/office/powerpoint/2010/main">
-        <p14:section name="Pembuka" id="{20b0996b-78ee-213a-9300-550e97529490}">
+        <p14:section name="Pembuka" id="{b13a9759-88cb-2398-3e51-2a2329db8f73}">
           <p14:sldIdLst>
             <p14:sldId id="256"/>
           </p14:sldIdLst>
         </p14:section>
-        <p14:section name="Aplikasi" id="{e61e9113-3bca-88ba-03fc-5a68933b455b}">
+        <p14:section name="Aplikasi" id="{40faf6d0-8130-ac3f-bb3a-cccca7bcbd34}">
           <p14:sldIdLst>
             <p14:sldId id="257"/>
             <p14:sldId id="258"/>
@@ -129,7 +129,7 @@
             <p14:sldId id="262"/>
           </p14:sldIdLst>
         </p14:section>
-        <p14:section name="Penutup" id="{4ce6378b-ed88-08ee-a4cd-2d804b2fef14}">
+        <p14:section name="Penutup" id="{e489a775-2c86-cb57-b94e-2a9926032cc5}">
           <p14:sldIdLst>
             <p14:sldId id="263"/>
           </p14:sldIdLst>
@@ -1898,42 +1898,6 @@
               <a:t>PT Pelita Indonesia Djaya (PELNI Services)</a:t>
             </a:r>
             <a:endParaRPr lang="en-US" sz="1600" dirty="0"/>
-          </a:p>
-        </p:txBody>
-      </p:sp>
-      <p:sp>
-        <p:nvSpPr>
-          <p:cNvPr id="5" name="Text 3"/>
-          <p:cNvSpPr txBox="1"/>
-          <p:nvPr/>
-        </p:nvSpPr>
-        <p:spPr>
-          <a:xfrm>
-            <a:off x="612648" y="4160520"/>
-            <a:ext cx="6766560" cy="365760"/>
-          </a:xfrm>
-          <a:prstGeom prst="rect">
-            <a:avLst/>
-          </a:prstGeom>
-          <a:noFill/>
-          <a:ln/>
-        </p:spPr>
-        <p:txBody>
-          <a:bodyPr wrap="square" lIns="0" tIns="0" rIns="0" bIns="0" rtlCol="0" anchor="t"/>
-          <a:lstStyle/>
-          <a:p>
-            <a:pPr indent="0" marL="0">
-              <a:buNone/>
-            </a:pPr>
-            <a:r>
-              <a:rPr lang="en-US" sz="1400" dirty="0">
-                <a:solidFill>
-                  <a:srgbClr val="A9C4EA"/>
-                </a:solidFill>
-              </a:rPr>
-              <a:t>Paparan kepada Direksi · Oktober 2026</a:t>
-            </a:r>
-            <a:endParaRPr lang="en-US" sz="1400" dirty="0"/>
           </a:p>
         </p:txBody>
       </p:sp>

</xml_diff>

<commit_message>
Paparan direksi template: hapus retur dan kas (belum digunakan)
Co-Authored-By: Claude Opus 5.5 <noreply@anthropic.com>
Claude-Session: https://claude.ai/code/session_01JEY5regGSA4jYBqyTUCMow
</commit_message>
<xml_diff>
--- a/docs/PID_POS_Paparan_Direksi_Template.pptx
+++ b/docs/PID_POS_Paparan_Direksi_Template.pptx
@@ -114,12 +114,12 @@
   <p:extLst>
     <p:ext uri="{521415D9-36F7-43E2-AB2F-B90AF26B5E84}">
       <p14:sectionLst xmlns:p14="http://schemas.microsoft.com/office/powerpoint/2010/main">
-        <p14:section name="Pembuka" id="{b13a9759-88cb-2398-3e51-2a2329db8f73}">
+        <p14:section name="Pembuka" id="{a246d58d-673d-62c2-343d-f44f0976fb23}">
           <p14:sldIdLst>
             <p14:sldId id="256"/>
           </p14:sldIdLst>
         </p14:section>
-        <p14:section name="Aplikasi" id="{40faf6d0-8130-ac3f-bb3a-cccca7bcbd34}">
+        <p14:section name="Aplikasi" id="{73ecabd6-a98c-efec-7b48-598297a97884}">
           <p14:sldIdLst>
             <p14:sldId id="257"/>
             <p14:sldId id="258"/>
@@ -129,7 +129,7 @@
             <p14:sldId id="262"/>
           </p14:sldIdLst>
         </p14:section>
-        <p14:section name="Penutup" id="{e489a775-2c86-cb57-b94e-2a9926032cc5}">
+        <p14:section name="Penutup" id="{4dd4af8b-0a74-d759-b251-92137b15ef5f}">
           <p14:sldIdLst>
             <p14:sldId id="263"/>
           </p14:sldIdLst>
@@ -1066,7 +1066,7 @@
           <a:p>
             <a:r>
               <a:rPr lang="en-US" dirty="0"/>
-              <a:t>Keunggulan PID POS ada tiga. Transparan: stok setiap dek dan status permintaan terpantau real-time. Terkendali: setiap tahap disetujui berjenjang, dan transaksi sensitif seperti retur memerlukan PIN kepala toko. Terintegrasi: dokumen SAP dibuat otomatis, termasuk penjualan harian setiap dek sebagai Delivery Order.</a:t>
+              <a:t>Keunggulan PID POS ada tiga. Transparan: stok setiap dek dan status permintaan terpantau real-time. Terkendali: setiap tahap disetujui berjenjang, dan setiap persetujuan tercatat lengkap dengan siapa dan kapan. Terintegrasi: dokumen SAP dibuat otomatis, termasuk penjualan harian setiap dek sebagai Delivery Order.</a:t>
             </a:r>
             <a:endParaRPr lang="en-US" dirty="0"/>
           </a:p>
@@ -2057,7 +2057,7 @@
                   <a:srgbClr val="1B2437"/>
                 </a:solidFill>
               </a:rPr>
-              <a:t>Untuk admin kapal, DC, dan kantor pusat: pesan barang, persetujuan, stok, kas, dan laporan.</a:t>
+              <a:t>Untuk admin kapal, DC, dan kantor pusat: pesan barang, persetujuan, stok, dan laporan.</a:t>
             </a:r>
             <a:endParaRPr lang="en-US" sz="1900" dirty="0"/>
           </a:p>
@@ -6579,7 +6579,7 @@
                   <a:srgbClr val="1B2437"/>
                 </a:solidFill>
               </a:rPr>
-              <a:t>Persetujuan berjenjang di setiap tahap; retur dan kas keluar besar memerlukan PIN kepala toko.</a:t>
+              <a:t>Persetujuan berjenjang di setiap tahap, dan setiap persetujuan tercatat lengkap dengan siapa dan kapan.</a:t>
             </a:r>
             <a:endParaRPr lang="en-US" sz="1400" dirty="0"/>
           </a:p>

</xml_diff>

<commit_message>
Deck direksi: istilah ditulis lengkap di awal, tambah keterangan dokumen SAP
Co-Authored-By: Claude Opus 5.5 <noreply@anthropic.com>
Claude-Session: https://claude.ai/code/session_01JEY5regGSA4jYBqyTUCMow
</commit_message>
<xml_diff>
--- a/docs/PID_POS_Paparan_Direksi_Template.pptx
+++ b/docs/PID_POS_Paparan_Direksi_Template.pptx
@@ -114,12 +114,12 @@
   <p:extLst>
     <p:ext uri="{521415D9-36F7-43E2-AB2F-B90AF26B5E84}">
       <p14:sectionLst xmlns:p14="http://schemas.microsoft.com/office/powerpoint/2010/main">
-        <p14:section name="Pembuka" id="{a246d58d-673d-62c2-343d-f44f0976fb23}">
+        <p14:section name="Pembuka" id="{1ac08df1-fef5-5067-460b-977c58a60feb}">
           <p14:sldIdLst>
             <p14:sldId id="256"/>
           </p14:sldIdLst>
         </p14:section>
-        <p14:section name="Aplikasi" id="{73ecabd6-a98c-efec-7b48-598297a97884}">
+        <p14:section name="Aplikasi" id="{81d8d1a3-b1c6-91e1-a87e-b23a6c8b8e29}">
           <p14:sldIdLst>
             <p14:sldId id="257"/>
             <p14:sldId id="258"/>
@@ -129,7 +129,7 @@
             <p14:sldId id="262"/>
           </p14:sldIdLst>
         </p14:section>
-        <p14:section name="Penutup" id="{4dd4af8b-0a74-d759-b251-92137b15ef5f}">
+        <p14:section name="Penutup" id="{bae6b110-b689-8b6b-4673-71f5cacc5380}">
           <p14:sldIdLst>
             <p14:sldId id="263"/>
           </p14:sldIdLst>
@@ -626,7 +626,7 @@
           <a:p>
             <a:r>
               <a:rPr lang="en-US" dirty="0"/>
-              <a:t>PID POS terdiri dari aplikasi web untuk admin kapal, DC, dan kantor pusat, serta aplikasi kasir Android untuk setiap dek. Keduanya terhubung langsung dengan SAP Business One, sehingga dokumen dibuat otomatis setelah disetujui.</a:t>
+              <a:t>PID POS terdiri dari aplikasi web untuk admin kapal, Distribution Center atau DC, dan kantor pusat, serta aplikasi kasir Android untuk setiap dek. Keduanya terhubung langsung dengan SAP Business One, sehingga dokumen dibuat otomatis setelah disetujui.</a:t>
             </a:r>
             <a:endParaRPr lang="en-US" dirty="0"/>
           </a:p>
@@ -714,7 +714,7 @@
           <a:p>
             <a:r>
               <a:rPr lang="en-US" dirty="0"/>
-              <a:t>Jalur atas selalu dijalani: kapal memesan ke DC, kantor pusat menyetujui sehingga Sales Order terbentuk di SAP, DC memilah stok, barang dikirim ke dek dengan Inventory Transfer, diterima kepala toko dan P2, lalu dijual di kasir dan masuk SAP sebagai Delivery Order. Bila stok DC kurang, jalur pembelian berjalan: Purchase Request, Purchase Order ke vendor, dan GRPO saat barang tiba di DC.</a:t>
+              <a:t>Jalur atas selalu dijalani: kapal memesan ke DC, kantor pusat menyetujui sehingga Sales Order terbentuk di SAP, DC memilah stok, barang dikirim ke dek dengan Inventory Transfer, diterima kepala toko, lalu dijual di kasir dan masuk SAP sebagai Delivery Order. Bila stok DC kurang, jalur pembelian berjalan: Purchase Request, Purchase Order ke vendor, dan Goods Receipt PO (GRPO) saat barang tiba di DC.</a:t>
             </a:r>
             <a:endParaRPr lang="en-US" dirty="0"/>
           </a:p>
@@ -802,7 +802,7 @@
           <a:p>
             <a:r>
               <a:rPr lang="en-US" dirty="0"/>
-              <a:t>Ada tujuh peran. Di kapal: admin kapal atau kepala toko, dan kasir. Di kantor pusat: Approve SO, Approve PUR, Admin Purchase, dan Approve PO. Di DC: admin DC. Setiap peran hanya melihat tugas yang menunggunya, lewat lonceng dan tab Giliran saya.</a:t>
+              <a:t>Ada tujuh peran. Di kapal: admin kapal atau kepala toko, dan kasir. Di kantor pusat: Approve Sales Order, Approve Purchasing, Admin Purchase, dan Approve Purchase Order. Di DC: admin DC. Setiap peran hanya melihat tugas yang menunggunya, lewat lonceng dan tab Giliran saya.</a:t>
             </a:r>
             <a:endParaRPr lang="en-US" dirty="0"/>
           </a:p>
@@ -2057,7 +2057,7 @@
                   <a:srgbClr val="1B2437"/>
                 </a:solidFill>
               </a:rPr>
-              <a:t>Untuk admin kapal, DC, dan kantor pusat: pesan barang, persetujuan, stok, dan laporan.</a:t>
+              <a:t>Untuk admin kapal, Distribution Center (DC), dan kantor pusat: pesan barang, persetujuan, stok, dan laporan.</a:t>
             </a:r>
             <a:endParaRPr lang="en-US" sz="1900" dirty="0"/>
           </a:p>
@@ -2537,7 +2537,7 @@
       </p:sp>
       <p:sp>
         <p:nvSpPr>
-          <p:cNvPr id="6" name="Tahap Approve SO"/>
+          <p:cNvPr id="6" name="Tahap Persetujuan permintaan"/>
           <p:cNvSpPr/>
           <p:nvPr/>
         </p:nvSpPr>
@@ -2599,7 +2599,7 @@
                   <a:srgbClr val="274289"/>
                 </a:solidFill>
               </a:rPr>
-              <a:t>Approve SO</a:t>
+              <a:t>Persetujuan permintaan</a:t>
             </a:r>
             <a:endParaRPr lang="en-US" sz="1500" dirty="0"/>
           </a:p>
@@ -3063,7 +3063,7 @@
                   <a:srgbClr val="5B6B86"/>
                 </a:solidFill>
               </a:rPr>
-              <a:t>Kepala toko · P2</a:t>
+              <a:t>Kepala toko</a:t>
             </a:r>
             <a:endParaRPr lang="en-US" sz="1500" dirty="0"/>
           </a:p>
@@ -3302,7 +3302,7 @@
       </p:sp>
       <p:sp>
         <p:nvSpPr>
-          <p:cNvPr id="28" name="Cabang Purchase Request"/>
+          <p:cNvPr id="28" name="Cabang Permintaan pembelian"/>
           <p:cNvSpPr/>
           <p:nvPr/>
         </p:nvSpPr>
@@ -3364,7 +3364,7 @@
                   <a:srgbClr val="274289"/>
                 </a:solidFill>
               </a:rPr>
-              <a:t>Purchase Request</a:t>
+              <a:t>Permintaan pembelian</a:t>
             </a:r>
             <a:endParaRPr lang="en-US" sz="1400" dirty="0"/>
           </a:p>
@@ -3378,7 +3378,7 @@
                   <a:srgbClr val="5B6B86"/>
                 </a:solidFill>
               </a:rPr>
-              <a:t>Approve PUR</a:t>
+              <a:t>Kantor pusat</a:t>
             </a:r>
             <a:endParaRPr lang="en-US" sz="1400" dirty="0"/>
           </a:p>
@@ -3473,7 +3473,7 @@
       </p:sp>
       <p:sp>
         <p:nvSpPr>
-          <p:cNvPr id="33" name="Cabang Purchase Order"/>
+          <p:cNvPr id="33" name="Cabang Pesanan ke vendor"/>
           <p:cNvSpPr/>
           <p:nvPr/>
         </p:nvSpPr>
@@ -3535,7 +3535,7 @@
                   <a:srgbClr val="274289"/>
                 </a:solidFill>
               </a:rPr>
-              <a:t>Purchase Order</a:t>
+              <a:t>Pesanan ke vendor</a:t>
             </a:r>
             <a:endParaRPr lang="en-US" sz="1400" dirty="0"/>
           </a:p>
@@ -3815,18 +3815,18 @@
       </p:sp>
       <p:sp>
         <p:nvSpPr>
-          <p:cNvPr id="43" name="Kesimpulan alur"/>
+          <p:cNvPr id="43" name="Keterangan dokumen SAP"/>
           <p:cNvSpPr/>
           <p:nvPr/>
         </p:nvSpPr>
         <p:spPr>
           <a:xfrm>
-            <a:off x="1600200" y="5074920"/>
-            <a:ext cx="9921240" cy="731520"/>
+            <a:off x="1600200" y="4892040"/>
+            <a:ext cx="9921240" cy="1188720"/>
           </a:xfrm>
           <a:prstGeom prst="roundRect">
             <a:avLst>
-              <a:gd name="adj" fmla="val 15000"/>
+              <a:gd name="adj" fmla="val 9231"/>
             </a:avLst>
           </a:prstGeom>
           <a:solidFill>
@@ -3855,8 +3855,8 @@
         </p:nvSpPr>
         <p:spPr>
           <a:xfrm>
-            <a:off x="1874520" y="5074920"/>
-            <a:ext cx="9464040" cy="731520"/>
+            <a:off x="1828800" y="4965192"/>
+            <a:ext cx="5486400" cy="274320"/>
           </a:xfrm>
           <a:prstGeom prst="rect">
             <a:avLst/>
@@ -3865,32 +3865,681 @@
           <a:ln/>
         </p:spPr>
         <p:txBody>
+          <a:bodyPr wrap="square" lIns="0" tIns="0" rIns="0" bIns="0" rtlCol="0" anchor="t"/>
+          <a:lstStyle/>
+          <a:p>
+            <a:pPr indent="0" marL="0">
+              <a:buNone/>
+            </a:pPr>
+            <a:r>
+              <a:rPr lang="en-US" sz="1300" b="1" dirty="0">
+                <a:solidFill>
+                  <a:srgbClr val="274289"/>
+                </a:solidFill>
+              </a:rPr>
+              <a:t>Dokumen SAP yang dibuat otomatis:</a:t>
+            </a:r>
+            <a:endParaRPr lang="en-US" sz="1300" dirty="0"/>
+          </a:p>
+        </p:txBody>
+      </p:sp>
+      <p:sp>
+        <p:nvSpPr>
+          <p:cNvPr id="45" name="Keterangan SO"/>
+          <p:cNvSpPr/>
+          <p:nvPr/>
+        </p:nvSpPr>
+        <p:spPr>
+          <a:xfrm>
+            <a:off x="1828800" y="5303520"/>
+            <a:ext cx="658368" cy="274320"/>
+          </a:xfrm>
+          <a:prstGeom prst="roundRect">
+            <a:avLst>
+              <a:gd name="adj" fmla="val 20000"/>
+            </a:avLst>
+          </a:prstGeom>
+          <a:solidFill>
+            <a:srgbClr val="4A8A3C"/>
+          </a:solidFill>
+          <a:ln w="12700">
+            <a:solidFill>
+              <a:srgbClr val="4A8A3C"/>
+            </a:solidFill>
+            <a:prstDash val="solid"/>
+          </a:ln>
+        </p:spPr>
+      </p:sp>
+      <p:sp>
+        <p:nvSpPr>
+          <p:cNvPr id="46" name="Text 44"/>
+          <p:cNvSpPr txBox="1"/>
+          <p:nvPr/>
+        </p:nvSpPr>
+        <p:spPr>
+          <a:xfrm>
+            <a:off x="1828800" y="5303520"/>
+            <a:ext cx="658368" cy="274320"/>
+          </a:xfrm>
+          <a:prstGeom prst="rect">
+            <a:avLst/>
+          </a:prstGeom>
+          <a:noFill/>
+          <a:ln/>
+        </p:spPr>
+        <p:txBody>
           <a:bodyPr wrap="square" lIns="0" tIns="0" rIns="0" bIns="0" rtlCol="0" anchor="ctr"/>
           <a:lstStyle/>
           <a:p>
+            <a:pPr algn="ctr" indent="0" marL="0">
+              <a:buNone/>
+            </a:pPr>
+            <a:r>
+              <a:rPr lang="en-US" sz="1100" b="1" dirty="0">
+                <a:solidFill>
+                  <a:srgbClr val="FFFFFF"/>
+                </a:solidFill>
+              </a:rPr>
+              <a:t>SO</a:t>
+            </a:r>
+            <a:endParaRPr lang="en-US" sz="1100" dirty="0"/>
+          </a:p>
+        </p:txBody>
+      </p:sp>
+      <p:sp>
+        <p:nvSpPr>
+          <p:cNvPr id="47" name="Text 45"/>
+          <p:cNvSpPr txBox="1"/>
+          <p:nvPr/>
+        </p:nvSpPr>
+        <p:spPr>
+          <a:xfrm>
+            <a:off x="2578608" y="5285232"/>
+            <a:ext cx="2423160" cy="310896"/>
+          </a:xfrm>
+          <a:prstGeom prst="rect">
+            <a:avLst/>
+          </a:prstGeom>
+          <a:noFill/>
+          <a:ln/>
+        </p:spPr>
+        <p:txBody>
+          <a:bodyPr wrap="square" lIns="0" tIns="0" rIns="0" bIns="0" rtlCol="0" anchor="ctr"/>
+          <a:lstStyle/>
+          <a:p>
             <a:pPr indent="0" marL="0">
               <a:buNone/>
             </a:pPr>
             <a:r>
-              <a:rPr lang="en-US" sz="1500" b="1" dirty="0">
+              <a:rPr lang="en-US" sz="1200" b="1" dirty="0">
                 <a:solidFill>
                   <a:srgbClr val="274289"/>
                 </a:solidFill>
               </a:rPr>
-              <a:t>6 jenis dokumen SAP dibuat otomatis: </a:t>
+              <a:t>Sales Order</a:t>
             </a:r>
             <a:pPr indent="0" marL="0">
               <a:buNone/>
             </a:pPr>
             <a:r>
-              <a:rPr lang="en-US" sz="1500" dirty="0">
-                <a:solidFill>
-                  <a:srgbClr val="1B2437"/>
-                </a:solidFill>
-              </a:rPr>
-              <a:t>SO, PR, PO, GRPO, IT, dan DO, tanpa input ulang.</a:t>
-            </a:r>
-            <a:endParaRPr lang="en-US" sz="1500" dirty="0"/>
+              <a:rPr lang="en-US" sz="1200" dirty="0">
+                <a:solidFill>
+                  <a:srgbClr val="5B6B86"/>
+                </a:solidFill>
+              </a:rPr>
+              <a:t> · pesanan per dek</a:t>
+            </a:r>
+            <a:endParaRPr lang="en-US" sz="1200" dirty="0"/>
+          </a:p>
+        </p:txBody>
+      </p:sp>
+      <p:sp>
+        <p:nvSpPr>
+          <p:cNvPr id="48" name="Keterangan PR"/>
+          <p:cNvSpPr/>
+          <p:nvPr/>
+        </p:nvSpPr>
+        <p:spPr>
+          <a:xfrm>
+            <a:off x="5074920" y="5303520"/>
+            <a:ext cx="658368" cy="274320"/>
+          </a:xfrm>
+          <a:prstGeom prst="roundRect">
+            <a:avLst>
+              <a:gd name="adj" fmla="val 20000"/>
+            </a:avLst>
+          </a:prstGeom>
+          <a:solidFill>
+            <a:srgbClr val="A87412"/>
+          </a:solidFill>
+          <a:ln w="12700">
+            <a:solidFill>
+              <a:srgbClr val="A87412"/>
+            </a:solidFill>
+            <a:prstDash val="solid"/>
+          </a:ln>
+        </p:spPr>
+      </p:sp>
+      <p:sp>
+        <p:nvSpPr>
+          <p:cNvPr id="49" name="Text 47"/>
+          <p:cNvSpPr txBox="1"/>
+          <p:nvPr/>
+        </p:nvSpPr>
+        <p:spPr>
+          <a:xfrm>
+            <a:off x="5074920" y="5303520"/>
+            <a:ext cx="658368" cy="274320"/>
+          </a:xfrm>
+          <a:prstGeom prst="rect">
+            <a:avLst/>
+          </a:prstGeom>
+          <a:noFill/>
+          <a:ln/>
+        </p:spPr>
+        <p:txBody>
+          <a:bodyPr wrap="square" lIns="0" tIns="0" rIns="0" bIns="0" rtlCol="0" anchor="ctr"/>
+          <a:lstStyle/>
+          <a:p>
+            <a:pPr algn="ctr" indent="0" marL="0">
+              <a:buNone/>
+            </a:pPr>
+            <a:r>
+              <a:rPr lang="en-US" sz="1100" b="1" dirty="0">
+                <a:solidFill>
+                  <a:srgbClr val="FFFFFF"/>
+                </a:solidFill>
+              </a:rPr>
+              <a:t>PR</a:t>
+            </a:r>
+            <a:endParaRPr lang="en-US" sz="1100" dirty="0"/>
+          </a:p>
+        </p:txBody>
+      </p:sp>
+      <p:sp>
+        <p:nvSpPr>
+          <p:cNvPr id="50" name="Text 48"/>
+          <p:cNvSpPr txBox="1"/>
+          <p:nvPr/>
+        </p:nvSpPr>
+        <p:spPr>
+          <a:xfrm>
+            <a:off x="5824728" y="5285232"/>
+            <a:ext cx="2423160" cy="310896"/>
+          </a:xfrm>
+          <a:prstGeom prst="rect">
+            <a:avLst/>
+          </a:prstGeom>
+          <a:noFill/>
+          <a:ln/>
+        </p:spPr>
+        <p:txBody>
+          <a:bodyPr wrap="square" lIns="0" tIns="0" rIns="0" bIns="0" rtlCol="0" anchor="ctr"/>
+          <a:lstStyle/>
+          <a:p>
+            <a:pPr indent="0" marL="0">
+              <a:buNone/>
+            </a:pPr>
+            <a:r>
+              <a:rPr lang="en-US" sz="1200" b="1" dirty="0">
+                <a:solidFill>
+                  <a:srgbClr val="274289"/>
+                </a:solidFill>
+              </a:rPr>
+              <a:t>Purchase Request</a:t>
+            </a:r>
+            <a:pPr indent="0" marL="0">
+              <a:buNone/>
+            </a:pPr>
+            <a:r>
+              <a:rPr lang="en-US" sz="1200" dirty="0">
+                <a:solidFill>
+                  <a:srgbClr val="5B6B86"/>
+                </a:solidFill>
+              </a:rPr>
+              <a:t> · permintaan pembelian</a:t>
+            </a:r>
+            <a:endParaRPr lang="en-US" sz="1200" dirty="0"/>
+          </a:p>
+        </p:txBody>
+      </p:sp>
+      <p:sp>
+        <p:nvSpPr>
+          <p:cNvPr id="51" name="Keterangan PO"/>
+          <p:cNvSpPr/>
+          <p:nvPr/>
+        </p:nvSpPr>
+        <p:spPr>
+          <a:xfrm>
+            <a:off x="8321040" y="5303520"/>
+            <a:ext cx="658368" cy="274320"/>
+          </a:xfrm>
+          <a:prstGeom prst="roundRect">
+            <a:avLst>
+              <a:gd name="adj" fmla="val 20000"/>
+            </a:avLst>
+          </a:prstGeom>
+          <a:solidFill>
+            <a:srgbClr val="C85A1C"/>
+          </a:solidFill>
+          <a:ln w="12700">
+            <a:solidFill>
+              <a:srgbClr val="C85A1C"/>
+            </a:solidFill>
+            <a:prstDash val="solid"/>
+          </a:ln>
+        </p:spPr>
+      </p:sp>
+      <p:sp>
+        <p:nvSpPr>
+          <p:cNvPr id="52" name="Text 50"/>
+          <p:cNvSpPr txBox="1"/>
+          <p:nvPr/>
+        </p:nvSpPr>
+        <p:spPr>
+          <a:xfrm>
+            <a:off x="8321040" y="5303520"/>
+            <a:ext cx="658368" cy="274320"/>
+          </a:xfrm>
+          <a:prstGeom prst="rect">
+            <a:avLst/>
+          </a:prstGeom>
+          <a:noFill/>
+          <a:ln/>
+        </p:spPr>
+        <p:txBody>
+          <a:bodyPr wrap="square" lIns="0" tIns="0" rIns="0" bIns="0" rtlCol="0" anchor="ctr"/>
+          <a:lstStyle/>
+          <a:p>
+            <a:pPr algn="ctr" indent="0" marL="0">
+              <a:buNone/>
+            </a:pPr>
+            <a:r>
+              <a:rPr lang="en-US" sz="1100" b="1" dirty="0">
+                <a:solidFill>
+                  <a:srgbClr val="FFFFFF"/>
+                </a:solidFill>
+              </a:rPr>
+              <a:t>PO</a:t>
+            </a:r>
+            <a:endParaRPr lang="en-US" sz="1100" dirty="0"/>
+          </a:p>
+        </p:txBody>
+      </p:sp>
+      <p:sp>
+        <p:nvSpPr>
+          <p:cNvPr id="53" name="Text 51"/>
+          <p:cNvSpPr txBox="1"/>
+          <p:nvPr/>
+        </p:nvSpPr>
+        <p:spPr>
+          <a:xfrm>
+            <a:off x="9070848" y="5285232"/>
+            <a:ext cx="2423160" cy="310896"/>
+          </a:xfrm>
+          <a:prstGeom prst="rect">
+            <a:avLst/>
+          </a:prstGeom>
+          <a:noFill/>
+          <a:ln/>
+        </p:spPr>
+        <p:txBody>
+          <a:bodyPr wrap="square" lIns="0" tIns="0" rIns="0" bIns="0" rtlCol="0" anchor="ctr"/>
+          <a:lstStyle/>
+          <a:p>
+            <a:pPr indent="0" marL="0">
+              <a:buNone/>
+            </a:pPr>
+            <a:r>
+              <a:rPr lang="en-US" sz="1200" b="1" dirty="0">
+                <a:solidFill>
+                  <a:srgbClr val="274289"/>
+                </a:solidFill>
+              </a:rPr>
+              <a:t>Purchase Order</a:t>
+            </a:r>
+            <a:pPr indent="0" marL="0">
+              <a:buNone/>
+            </a:pPr>
+            <a:r>
+              <a:rPr lang="en-US" sz="1200" dirty="0">
+                <a:solidFill>
+                  <a:srgbClr val="5B6B86"/>
+                </a:solidFill>
+              </a:rPr>
+              <a:t> · pesanan ke vendor</a:t>
+            </a:r>
+            <a:endParaRPr lang="en-US" sz="1200" dirty="0"/>
+          </a:p>
+        </p:txBody>
+      </p:sp>
+      <p:sp>
+        <p:nvSpPr>
+          <p:cNvPr id="54" name="Keterangan GRPO"/>
+          <p:cNvSpPr/>
+          <p:nvPr/>
+        </p:nvSpPr>
+        <p:spPr>
+          <a:xfrm>
+            <a:off x="1828800" y="5669280"/>
+            <a:ext cx="658368" cy="274320"/>
+          </a:xfrm>
+          <a:prstGeom prst="roundRect">
+            <a:avLst>
+              <a:gd name="adj" fmla="val 20000"/>
+            </a:avLst>
+          </a:prstGeom>
+          <a:solidFill>
+            <a:srgbClr val="7C68B8"/>
+          </a:solidFill>
+          <a:ln w="12700">
+            <a:solidFill>
+              <a:srgbClr val="7C68B8"/>
+            </a:solidFill>
+            <a:prstDash val="solid"/>
+          </a:ln>
+        </p:spPr>
+      </p:sp>
+      <p:sp>
+        <p:nvSpPr>
+          <p:cNvPr id="55" name="Text 53"/>
+          <p:cNvSpPr txBox="1"/>
+          <p:nvPr/>
+        </p:nvSpPr>
+        <p:spPr>
+          <a:xfrm>
+            <a:off x="1828800" y="5669280"/>
+            <a:ext cx="658368" cy="274320"/>
+          </a:xfrm>
+          <a:prstGeom prst="rect">
+            <a:avLst/>
+          </a:prstGeom>
+          <a:noFill/>
+          <a:ln/>
+        </p:spPr>
+        <p:txBody>
+          <a:bodyPr wrap="square" lIns="0" tIns="0" rIns="0" bIns="0" rtlCol="0" anchor="ctr"/>
+          <a:lstStyle/>
+          <a:p>
+            <a:pPr algn="ctr" indent="0" marL="0">
+              <a:buNone/>
+            </a:pPr>
+            <a:r>
+              <a:rPr lang="en-US" sz="1100" b="1" dirty="0">
+                <a:solidFill>
+                  <a:srgbClr val="FFFFFF"/>
+                </a:solidFill>
+              </a:rPr>
+              <a:t>GRPO</a:t>
+            </a:r>
+            <a:endParaRPr lang="en-US" sz="1100" dirty="0"/>
+          </a:p>
+        </p:txBody>
+      </p:sp>
+      <p:sp>
+        <p:nvSpPr>
+          <p:cNvPr id="56" name="Text 54"/>
+          <p:cNvSpPr txBox="1"/>
+          <p:nvPr/>
+        </p:nvSpPr>
+        <p:spPr>
+          <a:xfrm>
+            <a:off x="2578608" y="5650992"/>
+            <a:ext cx="2423160" cy="310896"/>
+          </a:xfrm>
+          <a:prstGeom prst="rect">
+            <a:avLst/>
+          </a:prstGeom>
+          <a:noFill/>
+          <a:ln/>
+        </p:spPr>
+        <p:txBody>
+          <a:bodyPr wrap="square" lIns="0" tIns="0" rIns="0" bIns="0" rtlCol="0" anchor="ctr"/>
+          <a:lstStyle/>
+          <a:p>
+            <a:pPr indent="0" marL="0">
+              <a:buNone/>
+            </a:pPr>
+            <a:r>
+              <a:rPr lang="en-US" sz="1200" b="1" dirty="0">
+                <a:solidFill>
+                  <a:srgbClr val="274289"/>
+                </a:solidFill>
+              </a:rPr>
+              <a:t>Goods Receipt PO</a:t>
+            </a:r>
+            <a:pPr indent="0" marL="0">
+              <a:buNone/>
+            </a:pPr>
+            <a:r>
+              <a:rPr lang="en-US" sz="1200" dirty="0">
+                <a:solidFill>
+                  <a:srgbClr val="5B6B86"/>
+                </a:solidFill>
+              </a:rPr>
+              <a:t> · penerimaan barang vendor</a:t>
+            </a:r>
+            <a:endParaRPr lang="en-US" sz="1200" dirty="0"/>
+          </a:p>
+        </p:txBody>
+      </p:sp>
+      <p:sp>
+        <p:nvSpPr>
+          <p:cNvPr id="57" name="Keterangan IT"/>
+          <p:cNvSpPr/>
+          <p:nvPr/>
+        </p:nvSpPr>
+        <p:spPr>
+          <a:xfrm>
+            <a:off x="5074920" y="5669280"/>
+            <a:ext cx="658368" cy="274320"/>
+          </a:xfrm>
+          <a:prstGeom prst="roundRect">
+            <a:avLst>
+              <a:gd name="adj" fmla="val 20000"/>
+            </a:avLst>
+          </a:prstGeom>
+          <a:solidFill>
+            <a:srgbClr val="C45C8E"/>
+          </a:solidFill>
+          <a:ln w="12700">
+            <a:solidFill>
+              <a:srgbClr val="C45C8E"/>
+            </a:solidFill>
+            <a:prstDash val="solid"/>
+          </a:ln>
+        </p:spPr>
+      </p:sp>
+      <p:sp>
+        <p:nvSpPr>
+          <p:cNvPr id="58" name="Text 56"/>
+          <p:cNvSpPr txBox="1"/>
+          <p:nvPr/>
+        </p:nvSpPr>
+        <p:spPr>
+          <a:xfrm>
+            <a:off x="5074920" y="5669280"/>
+            <a:ext cx="658368" cy="274320"/>
+          </a:xfrm>
+          <a:prstGeom prst="rect">
+            <a:avLst/>
+          </a:prstGeom>
+          <a:noFill/>
+          <a:ln/>
+        </p:spPr>
+        <p:txBody>
+          <a:bodyPr wrap="square" lIns="0" tIns="0" rIns="0" bIns="0" rtlCol="0" anchor="ctr"/>
+          <a:lstStyle/>
+          <a:p>
+            <a:pPr algn="ctr" indent="0" marL="0">
+              <a:buNone/>
+            </a:pPr>
+            <a:r>
+              <a:rPr lang="en-US" sz="1100" b="1" dirty="0">
+                <a:solidFill>
+                  <a:srgbClr val="FFFFFF"/>
+                </a:solidFill>
+              </a:rPr>
+              <a:t>IT</a:t>
+            </a:r>
+            <a:endParaRPr lang="en-US" sz="1100" dirty="0"/>
+          </a:p>
+        </p:txBody>
+      </p:sp>
+      <p:sp>
+        <p:nvSpPr>
+          <p:cNvPr id="59" name="Text 57"/>
+          <p:cNvSpPr txBox="1"/>
+          <p:nvPr/>
+        </p:nvSpPr>
+        <p:spPr>
+          <a:xfrm>
+            <a:off x="5824728" y="5650992"/>
+            <a:ext cx="2423160" cy="310896"/>
+          </a:xfrm>
+          <a:prstGeom prst="rect">
+            <a:avLst/>
+          </a:prstGeom>
+          <a:noFill/>
+          <a:ln/>
+        </p:spPr>
+        <p:txBody>
+          <a:bodyPr wrap="square" lIns="0" tIns="0" rIns="0" bIns="0" rtlCol="0" anchor="ctr"/>
+          <a:lstStyle/>
+          <a:p>
+            <a:pPr indent="0" marL="0">
+              <a:buNone/>
+            </a:pPr>
+            <a:r>
+              <a:rPr lang="en-US" sz="1200" b="1" dirty="0">
+                <a:solidFill>
+                  <a:srgbClr val="274289"/>
+                </a:solidFill>
+              </a:rPr>
+              <a:t>Inventory Transfer</a:t>
+            </a:r>
+            <a:pPr indent="0" marL="0">
+              <a:buNone/>
+            </a:pPr>
+            <a:r>
+              <a:rPr lang="en-US" sz="1200" dirty="0">
+                <a:solidFill>
+                  <a:srgbClr val="5B6B86"/>
+                </a:solidFill>
+              </a:rPr>
+              <a:t> · kiriman DC ke dek</a:t>
+            </a:r>
+            <a:endParaRPr lang="en-US" sz="1200" dirty="0"/>
+          </a:p>
+        </p:txBody>
+      </p:sp>
+      <p:sp>
+        <p:nvSpPr>
+          <p:cNvPr id="60" name="Keterangan DO"/>
+          <p:cNvSpPr/>
+          <p:nvPr/>
+        </p:nvSpPr>
+        <p:spPr>
+          <a:xfrm>
+            <a:off x="8321040" y="5669280"/>
+            <a:ext cx="658368" cy="274320"/>
+          </a:xfrm>
+          <a:prstGeom prst="roundRect">
+            <a:avLst>
+              <a:gd name="adj" fmla="val 20000"/>
+            </a:avLst>
+          </a:prstGeom>
+          <a:solidFill>
+            <a:srgbClr val="CF5140"/>
+          </a:solidFill>
+          <a:ln w="12700">
+            <a:solidFill>
+              <a:srgbClr val="CF5140"/>
+            </a:solidFill>
+            <a:prstDash val="solid"/>
+          </a:ln>
+        </p:spPr>
+      </p:sp>
+      <p:sp>
+        <p:nvSpPr>
+          <p:cNvPr id="61" name="Text 59"/>
+          <p:cNvSpPr txBox="1"/>
+          <p:nvPr/>
+        </p:nvSpPr>
+        <p:spPr>
+          <a:xfrm>
+            <a:off x="8321040" y="5669280"/>
+            <a:ext cx="658368" cy="274320"/>
+          </a:xfrm>
+          <a:prstGeom prst="rect">
+            <a:avLst/>
+          </a:prstGeom>
+          <a:noFill/>
+          <a:ln/>
+        </p:spPr>
+        <p:txBody>
+          <a:bodyPr wrap="square" lIns="0" tIns="0" rIns="0" bIns="0" rtlCol="0" anchor="ctr"/>
+          <a:lstStyle/>
+          <a:p>
+            <a:pPr algn="ctr" indent="0" marL="0">
+              <a:buNone/>
+            </a:pPr>
+            <a:r>
+              <a:rPr lang="en-US" sz="1100" b="1" dirty="0">
+                <a:solidFill>
+                  <a:srgbClr val="FFFFFF"/>
+                </a:solidFill>
+              </a:rPr>
+              <a:t>DO</a:t>
+            </a:r>
+            <a:endParaRPr lang="en-US" sz="1100" dirty="0"/>
+          </a:p>
+        </p:txBody>
+      </p:sp>
+      <p:sp>
+        <p:nvSpPr>
+          <p:cNvPr id="62" name="Text 60"/>
+          <p:cNvSpPr txBox="1"/>
+          <p:nvPr/>
+        </p:nvSpPr>
+        <p:spPr>
+          <a:xfrm>
+            <a:off x="9070848" y="5650992"/>
+            <a:ext cx="2423160" cy="310896"/>
+          </a:xfrm>
+          <a:prstGeom prst="rect">
+            <a:avLst/>
+          </a:prstGeom>
+          <a:noFill/>
+          <a:ln/>
+        </p:spPr>
+        <p:txBody>
+          <a:bodyPr wrap="square" lIns="0" tIns="0" rIns="0" bIns="0" rtlCol="0" anchor="ctr"/>
+          <a:lstStyle/>
+          <a:p>
+            <a:pPr indent="0" marL="0">
+              <a:buNone/>
+            </a:pPr>
+            <a:r>
+              <a:rPr lang="en-US" sz="1200" b="1" dirty="0">
+                <a:solidFill>
+                  <a:srgbClr val="274289"/>
+                </a:solidFill>
+              </a:rPr>
+              <a:t>Delivery Order</a:t>
+            </a:r>
+            <a:pPr indent="0" marL="0">
+              <a:buNone/>
+            </a:pPr>
+            <a:r>
+              <a:rPr lang="en-US" sz="1200" dirty="0">
+                <a:solidFill>
+                  <a:srgbClr val="5B6B86"/>
+                </a:solidFill>
+              </a:rPr>
+              <a:t> · penjualan harian kasir</a:t>
+            </a:r>
+            <a:endParaRPr lang="en-US" sz="1200" dirty="0"/>
           </a:p>
         </p:txBody>
       </p:sp>
@@ -4283,7 +4932,7 @@
                   <a:srgbClr val="5B6B86"/>
                 </a:solidFill>
               </a:rPr>
-              <a:t>Jual, kirim DO harian ke SAP</a:t>
+              <a:t>Jual, kirim penjualan harian ke SAP</a:t>
             </a:r>
             <a:endParaRPr lang="en-US" sz="1500" dirty="0"/>
           </a:p>
@@ -4410,7 +5059,7 @@
       </p:sp>
       <p:sp>
         <p:nvSpPr>
-          <p:cNvPr id="15" name="Peran Approve SO (P2)"/>
+          <p:cNvPr id="15" name="Peran Approve Sales Order"/>
           <p:cNvSpPr/>
           <p:nvPr/>
         </p:nvSpPr>
@@ -4472,7 +5121,7 @@
                   <a:srgbClr val="274289"/>
                 </a:solidFill>
               </a:rPr>
-              <a:t>Approve SO (P2)</a:t>
+              <a:t>Approve Sales Order</a:t>
             </a:r>
             <a:endParaRPr lang="en-US" sz="1500" dirty="0"/>
           </a:p>
@@ -4486,7 +5135,7 @@
                   <a:srgbClr val="5B6B86"/>
                 </a:solidFill>
               </a:rPr>
-              <a:t>Setujui permintaan jadi Sales Order</a:t>
+              <a:t>Setujui permintaan kapal ke DC</a:t>
             </a:r>
             <a:endParaRPr lang="en-US" sz="1500" dirty="0"/>
           </a:p>
@@ -4494,7 +5143,7 @@
       </p:sp>
       <p:sp>
         <p:nvSpPr>
-          <p:cNvPr id="17" name="Peran Approve PUR"/>
+          <p:cNvPr id="17" name="Peran Approve Purchasing"/>
           <p:cNvSpPr/>
           <p:nvPr/>
         </p:nvSpPr>
@@ -4556,7 +5205,7 @@
                   <a:srgbClr val="274289"/>
                 </a:solidFill>
               </a:rPr>
-              <a:t>Approve PUR</a:t>
+              <a:t>Approve Purchasing</a:t>
             </a:r>
             <a:endParaRPr lang="en-US" sz="1500" dirty="0"/>
           </a:p>
@@ -4570,7 +5219,7 @@
                   <a:srgbClr val="5B6B86"/>
                 </a:solidFill>
               </a:rPr>
-              <a:t>Setujui PR, GRPO, dan transfer</a:t>
+              <a:t>Setujui pembelian, penerimaan, transfer</a:t>
             </a:r>
             <a:endParaRPr lang="en-US" sz="1500" dirty="0"/>
           </a:p>
@@ -4662,7 +5311,7 @@
       </p:sp>
       <p:sp>
         <p:nvSpPr>
-          <p:cNvPr id="21" name="Peran Approve PO"/>
+          <p:cNvPr id="21" name="Peran Approve Purchase Order"/>
           <p:cNvSpPr/>
           <p:nvPr/>
         </p:nvSpPr>
@@ -4724,7 +5373,7 @@
                   <a:srgbClr val="274289"/>
                 </a:solidFill>
               </a:rPr>
-              <a:t>Approve PO</a:t>
+              <a:t>Approve Purchase Order</a:t>
             </a:r>
             <a:endParaRPr lang="en-US" sz="1500" dirty="0"/>
           </a:p>
@@ -4738,7 +5387,7 @@
                   <a:srgbClr val="5B6B86"/>
                 </a:solidFill>
               </a:rPr>
-              <a:t>Setujui Purchase Order</a:t>
+              <a:t>Setujui pesanan ke vendor</a:t>
             </a:r>
             <a:endParaRPr lang="en-US" sz="1500" dirty="0"/>
           </a:p>
@@ -4941,7 +5590,7 @@
                   <a:srgbClr val="5B6B86"/>
                 </a:solidFill>
               </a:rPr>
-              <a:t>Pilah stok, ajukan GRPO dan transfer</a:t>
+              <a:t>Pilah stok, ajukan penerimaan dan transfer</a:t>
             </a:r>
             <a:endParaRPr lang="en-US" sz="1500" dirty="0"/>
           </a:p>
@@ -6147,7 +6796,7 @@
                   <a:srgbClr val="274289"/>
                 </a:solidFill>
               </a:rPr>
-              <a:t>Kirim DO</a:t>
+              <a:t>Kirim Delivery Order</a:t>
             </a:r>
             <a:endParaRPr lang="en-US" sz="1500" dirty="0"/>
           </a:p>
@@ -6734,7 +7383,7 @@
                   <a:srgbClr val="1B2437"/>
                 </a:solidFill>
               </a:rPr>
-              <a:t>Dokumen SAP Business One dibuat otomatis, dan penjualan harian setiap dek masuk SAP sebagai DO.</a:t>
+              <a:t>Dokumen SAP Business One dibuat otomatis, dan penjualan harian setiap dek masuk SAP sebagai Delivery Order.</a:t>
             </a:r>
             <a:endParaRPr lang="en-US" sz="1400" dirty="0"/>
           </a:p>

</xml_diff>

<commit_message>
Deck direksi: peran Approve PUR ditulis Approve Purchase Request
Co-Authored-By: Claude Opus 5.5 <noreply@anthropic.com>
Claude-Session: https://claude.ai/code/session_01JEY5regGSA4jYBqyTUCMow
</commit_message>
<xml_diff>
--- a/docs/PID_POS_Paparan_Direksi_Template.pptx
+++ b/docs/PID_POS_Paparan_Direksi_Template.pptx
@@ -114,12 +114,12 @@
   <p:extLst>
     <p:ext uri="{521415D9-36F7-43E2-AB2F-B90AF26B5E84}">
       <p14:sectionLst xmlns:p14="http://schemas.microsoft.com/office/powerpoint/2010/main">
-        <p14:section name="Pembuka" id="{1ac08df1-fef5-5067-460b-977c58a60feb}">
+        <p14:section name="Pembuka" id="{bf643f96-0843-573e-934a-10c7e32fb742}">
           <p14:sldIdLst>
             <p14:sldId id="256"/>
           </p14:sldIdLst>
         </p14:section>
-        <p14:section name="Aplikasi" id="{81d8d1a3-b1c6-91e1-a87e-b23a6c8b8e29}">
+        <p14:section name="Aplikasi" id="{481c1a25-3e99-6321-5252-cdd849a86a96}">
           <p14:sldIdLst>
             <p14:sldId id="257"/>
             <p14:sldId id="258"/>
@@ -129,7 +129,7 @@
             <p14:sldId id="262"/>
           </p14:sldIdLst>
         </p14:section>
-        <p14:section name="Penutup" id="{bae6b110-b689-8b6b-4673-71f5cacc5380}">
+        <p14:section name="Penutup" id="{d34dd72d-f2f4-7c3b-6703-45de7ee95f64}">
           <p14:sldIdLst>
             <p14:sldId id="263"/>
           </p14:sldIdLst>
@@ -802,7 +802,7 @@
           <a:p>
             <a:r>
               <a:rPr lang="en-US" dirty="0"/>
-              <a:t>Ada tujuh peran. Di kapal: admin kapal atau kepala toko, dan kasir. Di kantor pusat: Approve Sales Order, Approve Purchasing, Admin Purchase, dan Approve Purchase Order. Di DC: admin DC. Setiap peran hanya melihat tugas yang menunggunya, lewat lonceng dan tab Giliran saya.</a:t>
+              <a:t>Ada tujuh peran. Di kapal: admin kapal atau kepala toko, dan kasir. Di kantor pusat: Approve Sales Order, Approve Purchase Request, Admin Purchase, dan Approve Purchase Order. Di DC: admin DC. Setiap peran hanya melihat tugas yang menunggunya, lewat lonceng dan tab Giliran saya.</a:t>
             </a:r>
             <a:endParaRPr lang="en-US" dirty="0"/>
           </a:p>
@@ -5143,7 +5143,7 @@
       </p:sp>
       <p:sp>
         <p:nvSpPr>
-          <p:cNvPr id="17" name="Peran Approve Purchasing"/>
+          <p:cNvPr id="17" name="Peran Approve Purchase Request"/>
           <p:cNvSpPr/>
           <p:nvPr/>
         </p:nvSpPr>
@@ -5205,7 +5205,7 @@
                   <a:srgbClr val="274289"/>
                 </a:solidFill>
               </a:rPr>
-              <a:t>Approve Purchasing</a:t>
+              <a:t>Approve Purchase Request</a:t>
             </a:r>
             <a:endParaRPr lang="en-US" sz="1500" dirty="0"/>
           </a:p>

</xml_diff>

<commit_message>
Deck direksi: alur dibuat berulang, kasir kembali ke pesan ke DC
Co-Authored-By: Claude Opus 5.5 <noreply@anthropic.com>
Claude-Session: https://claude.ai/code/session_01JEY5regGSA4jYBqyTUCMow
</commit_message>
<xml_diff>
--- a/docs/PID_POS_Paparan_Direksi_Template.pptx
+++ b/docs/PID_POS_Paparan_Direksi_Template.pptx
@@ -114,12 +114,12 @@
   <p:extLst>
     <p:ext uri="{521415D9-36F7-43E2-AB2F-B90AF26B5E84}">
       <p14:sectionLst xmlns:p14="http://schemas.microsoft.com/office/powerpoint/2010/main">
-        <p14:section name="Pembuka" id="{bf643f96-0843-573e-934a-10c7e32fb742}">
+        <p14:section name="Pembuka" id="{86ca8375-290a-8062-43fb-ed5261ac01e7}">
           <p14:sldIdLst>
             <p14:sldId id="256"/>
           </p14:sldIdLst>
         </p14:section>
-        <p14:section name="Aplikasi" id="{481c1a25-3e99-6321-5252-cdd849a86a96}">
+        <p14:section name="Aplikasi" id="{2f4358db-82f4-41cf-d742-1083ca4d9d6c}">
           <p14:sldIdLst>
             <p14:sldId id="257"/>
             <p14:sldId id="258"/>
@@ -129,7 +129,7 @@
             <p14:sldId id="262"/>
           </p14:sldIdLst>
         </p14:section>
-        <p14:section name="Penutup" id="{d34dd72d-f2f4-7c3b-6703-45de7ee95f64}">
+        <p14:section name="Penutup" id="{b7941551-9dec-0452-cd03-b16037ab2d8d}">
           <p14:sldIdLst>
             <p14:sldId id="263"/>
           </p14:sldIdLst>
@@ -714,7 +714,7 @@
           <a:p>
             <a:r>
               <a:rPr lang="en-US" dirty="0"/>
-              <a:t>Jalur atas selalu dijalani: kapal memesan ke DC, kantor pusat menyetujui sehingga Sales Order terbentuk di SAP, DC memilah stok, barang dikirim ke dek dengan Inventory Transfer, diterima kepala toko, lalu dijual di kasir dan masuk SAP sebagai Delivery Order. Bila stok DC kurang, jalur pembelian berjalan: Purchase Request, Purchase Order ke vendor, dan Goods Receipt PO (GRPO) saat barang tiba di DC.</a:t>
+              <a:t>Jalur atas selalu dijalani: kapal memesan ke DC, kantor pusat menyetujui sehingga Sales Order terbentuk di SAP, DC memilah stok, barang dikirim ke dek dengan Inventory Transfer, diterima kepala toko, lalu dijual di kasir dan masuk SAP sebagai Delivery Order. Bila stok DC kurang, jalur pembelian berjalan: Purchase Request, Purchase Order ke vendor, dan Goods Receipt PO (GRPO) saat barang tiba di DC. Alur ini berulang: setelah barang terjual dan stok dek menipis, kapal memesan lagi ke DC.</a:t>
             </a:r>
             <a:endParaRPr lang="en-US" dirty="0"/>
           </a:p>
@@ -2435,7 +2435,7 @@
         </p:nvSpPr>
         <p:spPr>
           <a:xfrm>
-            <a:off x="685800" y="1783080"/>
+            <a:off x="685800" y="2011680"/>
             <a:ext cx="1627632" cy="960120"/>
           </a:xfrm>
           <a:prstGeom prst="roundRect">
@@ -2469,7 +2469,7 @@
         </p:nvSpPr>
         <p:spPr>
           <a:xfrm>
-            <a:off x="777240" y="1856232"/>
+            <a:off x="777240" y="2084832"/>
             <a:ext cx="1444752" cy="822960"/>
           </a:xfrm>
           <a:prstGeom prst="rect">
@@ -2519,7 +2519,7 @@
         </p:nvSpPr>
         <p:spPr>
           <a:xfrm>
-            <a:off x="2340864" y="2263140"/>
+            <a:off x="2340864" y="2491740"/>
             <a:ext cx="160020" cy="0"/>
           </a:xfrm>
           <a:prstGeom prst="line">
@@ -2543,7 +2543,7 @@
         </p:nvSpPr>
         <p:spPr>
           <a:xfrm>
-            <a:off x="2528316" y="1783080"/>
+            <a:off x="2528316" y="2011680"/>
             <a:ext cx="1627632" cy="960120"/>
           </a:xfrm>
           <a:prstGeom prst="roundRect">
@@ -2577,7 +2577,7 @@
         </p:nvSpPr>
         <p:spPr>
           <a:xfrm>
-            <a:off x="2619756" y="1856232"/>
+            <a:off x="2619756" y="2084832"/>
             <a:ext cx="1444752" cy="822960"/>
           </a:xfrm>
           <a:prstGeom prst="rect">
@@ -2627,7 +2627,7 @@
         </p:nvSpPr>
         <p:spPr>
           <a:xfrm>
-            <a:off x="4183380" y="2263140"/>
+            <a:off x="4183380" y="2491740"/>
             <a:ext cx="160020" cy="0"/>
           </a:xfrm>
           <a:prstGeom prst="line">
@@ -2651,7 +2651,7 @@
         </p:nvSpPr>
         <p:spPr>
           <a:xfrm>
-            <a:off x="2958084" y="2816352"/>
+            <a:off x="2958084" y="3044952"/>
             <a:ext cx="768096" cy="310896"/>
           </a:xfrm>
           <a:prstGeom prst="roundRect">
@@ -2678,7 +2678,7 @@
         </p:nvSpPr>
         <p:spPr>
           <a:xfrm>
-            <a:off x="2958084" y="2816352"/>
+            <a:off x="2958084" y="3044952"/>
             <a:ext cx="768096" cy="310896"/>
           </a:xfrm>
           <a:prstGeom prst="rect">
@@ -2714,7 +2714,7 @@
         </p:nvSpPr>
         <p:spPr>
           <a:xfrm>
-            <a:off x="4370832" y="1783080"/>
+            <a:off x="4370832" y="2011680"/>
             <a:ext cx="1627632" cy="960120"/>
           </a:xfrm>
           <a:prstGeom prst="roundRect">
@@ -2748,7 +2748,7 @@
         </p:nvSpPr>
         <p:spPr>
           <a:xfrm>
-            <a:off x="4462272" y="1856232"/>
+            <a:off x="4462272" y="2084832"/>
             <a:ext cx="1444752" cy="822960"/>
           </a:xfrm>
           <a:prstGeom prst="rect">
@@ -2798,7 +2798,7 @@
         </p:nvSpPr>
         <p:spPr>
           <a:xfrm>
-            <a:off x="6025896" y="2263140"/>
+            <a:off x="6025896" y="2491740"/>
             <a:ext cx="160020" cy="0"/>
           </a:xfrm>
           <a:prstGeom prst="line">
@@ -2822,7 +2822,7 @@
         </p:nvSpPr>
         <p:spPr>
           <a:xfrm>
-            <a:off x="6213348" y="1783080"/>
+            <a:off x="6213348" y="2011680"/>
             <a:ext cx="1627632" cy="960120"/>
           </a:xfrm>
           <a:prstGeom prst="roundRect">
@@ -2856,7 +2856,7 @@
         </p:nvSpPr>
         <p:spPr>
           <a:xfrm>
-            <a:off x="6304788" y="1856232"/>
+            <a:off x="6304788" y="2084832"/>
             <a:ext cx="1444752" cy="822960"/>
           </a:xfrm>
           <a:prstGeom prst="rect">
@@ -2906,7 +2906,7 @@
         </p:nvSpPr>
         <p:spPr>
           <a:xfrm>
-            <a:off x="7868412" y="2263140"/>
+            <a:off x="7868412" y="2491740"/>
             <a:ext cx="160020" cy="0"/>
           </a:xfrm>
           <a:prstGeom prst="line">
@@ -2930,7 +2930,7 @@
         </p:nvSpPr>
         <p:spPr>
           <a:xfrm>
-            <a:off x="6643116" y="2816352"/>
+            <a:off x="6643116" y="3044952"/>
             <a:ext cx="768096" cy="310896"/>
           </a:xfrm>
           <a:prstGeom prst="roundRect">
@@ -2957,7 +2957,7 @@
         </p:nvSpPr>
         <p:spPr>
           <a:xfrm>
-            <a:off x="6643116" y="2816352"/>
+            <a:off x="6643116" y="3044952"/>
             <a:ext cx="768096" cy="310896"/>
           </a:xfrm>
           <a:prstGeom prst="rect">
@@ -2993,7 +2993,7 @@
         </p:nvSpPr>
         <p:spPr>
           <a:xfrm>
-            <a:off x="8055864" y="1783080"/>
+            <a:off x="8055864" y="2011680"/>
             <a:ext cx="1627632" cy="960120"/>
           </a:xfrm>
           <a:prstGeom prst="roundRect">
@@ -3027,7 +3027,7 @@
         </p:nvSpPr>
         <p:spPr>
           <a:xfrm>
-            <a:off x="8147304" y="1856232"/>
+            <a:off x="8147304" y="2084832"/>
             <a:ext cx="1444752" cy="822960"/>
           </a:xfrm>
           <a:prstGeom prst="rect">
@@ -3077,7 +3077,7 @@
         </p:nvSpPr>
         <p:spPr>
           <a:xfrm>
-            <a:off x="9710928" y="2263140"/>
+            <a:off x="9710928" y="2491740"/>
             <a:ext cx="160020" cy="0"/>
           </a:xfrm>
           <a:prstGeom prst="line">
@@ -3101,7 +3101,7 @@
         </p:nvSpPr>
         <p:spPr>
           <a:xfrm>
-            <a:off x="9898380" y="1783080"/>
+            <a:off x="9898380" y="2011680"/>
             <a:ext cx="1627632" cy="960120"/>
           </a:xfrm>
           <a:prstGeom prst="roundRect">
@@ -3135,7 +3135,7 @@
         </p:nvSpPr>
         <p:spPr>
           <a:xfrm>
-            <a:off x="9989820" y="1856232"/>
+            <a:off x="9989820" y="2084832"/>
             <a:ext cx="1444752" cy="822960"/>
           </a:xfrm>
           <a:prstGeom prst="rect">
@@ -3185,7 +3185,7 @@
         </p:nvSpPr>
         <p:spPr>
           <a:xfrm>
-            <a:off x="10328148" y="2816352"/>
+            <a:off x="10328148" y="3044952"/>
             <a:ext cx="768096" cy="310896"/>
           </a:xfrm>
           <a:prstGeom prst="roundRect">
@@ -3212,7 +3212,7 @@
         </p:nvSpPr>
         <p:spPr>
           <a:xfrm>
-            <a:off x="10328148" y="2816352"/>
+            <a:off x="10328148" y="3044952"/>
             <a:ext cx="768096" cy="310896"/>
           </a:xfrm>
           <a:prstGeom prst="rect">
@@ -3242,13 +3242,121 @@
       </p:sp>
       <p:sp>
         <p:nvSpPr>
-          <p:cNvPr id="26" name="Text 24"/>
+          <p:cNvPr id="26" name="Siklus ulang"/>
+          <p:cNvSpPr/>
+          <p:nvPr/>
+        </p:nvSpPr>
+        <p:spPr>
+          <a:xfrm>
+            <a:off x="1499616" y="1737360"/>
+            <a:ext cx="9212580" cy="0"/>
+          </a:xfrm>
+          <a:prstGeom prst="line">
+            <a:avLst/>
+          </a:prstGeom>
+          <a:noFill/>
+          <a:ln w="28575">
+            <a:solidFill>
+              <a:srgbClr val="5AB4E5"/>
+            </a:solidFill>
+            <a:prstDash val="solid"/>
+          </a:ln>
+        </p:spPr>
+      </p:sp>
+      <p:sp>
+        <p:nvSpPr>
+          <p:cNvPr id="27" name="Siklus ulang dari kasir"/>
+          <p:cNvSpPr/>
+          <p:nvPr/>
+        </p:nvSpPr>
+        <p:spPr>
+          <a:xfrm>
+            <a:off x="10712196" y="1737360"/>
+            <a:ext cx="0" cy="274320"/>
+          </a:xfrm>
+          <a:prstGeom prst="line">
+            <a:avLst/>
+          </a:prstGeom>
+          <a:noFill/>
+          <a:ln w="28575">
+            <a:solidFill>
+              <a:srgbClr val="5AB4E5"/>
+            </a:solidFill>
+            <a:prstDash val="solid"/>
+          </a:ln>
+        </p:spPr>
+      </p:sp>
+      <p:sp>
+        <p:nvSpPr>
+          <p:cNvPr id="28" name="Siklus ulang ke pesan"/>
+          <p:cNvSpPr/>
+          <p:nvPr/>
+        </p:nvSpPr>
+        <p:spPr>
+          <a:xfrm>
+            <a:off x="1499616" y="1737360"/>
+            <a:ext cx="0" cy="256032"/>
+          </a:xfrm>
+          <a:prstGeom prst="line">
+            <a:avLst/>
+          </a:prstGeom>
+          <a:noFill/>
+          <a:ln w="28575">
+            <a:solidFill>
+              <a:srgbClr val="5AB4E5"/>
+            </a:solidFill>
+            <a:prstDash val="solid"/>
+            <a:tailEnd type="triangle"/>
+          </a:ln>
+        </p:spPr>
+      </p:sp>
+      <p:sp>
+        <p:nvSpPr>
+          <p:cNvPr id="29" name="Text 27"/>
           <p:cNvSpPr txBox="1"/>
           <p:nvPr/>
         </p:nvSpPr>
         <p:spPr>
           <a:xfrm>
-            <a:off x="685800" y="3675888"/>
+            <a:off x="4023360" y="1581912"/>
+            <a:ext cx="4206240" cy="310896"/>
+          </a:xfrm>
+          <a:prstGeom prst="rect">
+            <a:avLst/>
+          </a:prstGeom>
+          <a:solidFill>
+            <a:srgbClr val="FFFFFF"/>
+          </a:solidFill>
+          <a:ln/>
+        </p:spPr>
+        <p:txBody>
+          <a:bodyPr wrap="square" lIns="0" tIns="0" rIns="0" bIns="0" rtlCol="0" anchor="ctr"/>
+          <a:lstStyle/>
+          <a:p>
+            <a:pPr algn="ctr" indent="0" marL="0">
+              <a:buNone/>
+            </a:pPr>
+            <a:r>
+              <a:rPr lang="en-US" sz="1200" b="1" dirty="0">
+                <a:solidFill>
+                  <a:srgbClr val="5AB4E5"/>
+                </a:solidFill>
+              </a:rPr>
+              <a:t>↻  Stok dek menipis: kapal memesan lagi ke DC</a:t>
+            </a:r>
+            <a:endParaRPr lang="en-US" sz="1200" dirty="0"/>
+          </a:p>
+        </p:txBody>
+      </p:sp>
+      <p:sp>
+        <p:nvSpPr>
+          <p:cNvPr id="30" name="Text 28"/>
+          <p:cNvSpPr txBox="1"/>
+          <p:nvPr/>
+        </p:nvSpPr>
+        <p:spPr>
+          <a:xfrm>
+            <a:off x="685800" y="3858768"/>
             <a:ext cx="3520440" cy="365760"/>
           </a:xfrm>
           <a:prstGeom prst="rect">
@@ -3278,14 +3386,14 @@
       </p:sp>
       <p:sp>
         <p:nvSpPr>
-          <p:cNvPr id="27" name="Cabang pembelian"/>
+          <p:cNvPr id="31" name="Cabang pembelian"/>
           <p:cNvSpPr/>
           <p:nvPr/>
         </p:nvSpPr>
         <p:spPr>
           <a:xfrm>
-            <a:off x="5184648" y="2743200"/>
-            <a:ext cx="0" cy="640080"/>
+            <a:off x="5184648" y="2971800"/>
+            <a:ext cx="0" cy="594360"/>
           </a:xfrm>
           <a:prstGeom prst="line">
             <a:avLst/>
@@ -3302,13 +3410,13 @@
       </p:sp>
       <p:sp>
         <p:nvSpPr>
-          <p:cNvPr id="28" name="Cabang Permintaan pembelian"/>
+          <p:cNvPr id="32" name="Cabang Permintaan pembelian"/>
           <p:cNvSpPr/>
           <p:nvPr/>
         </p:nvSpPr>
         <p:spPr>
           <a:xfrm>
-            <a:off x="4370832" y="3383280"/>
+            <a:off x="4370832" y="3566160"/>
             <a:ext cx="1627632" cy="960120"/>
           </a:xfrm>
           <a:prstGeom prst="roundRect">
@@ -3336,13 +3444,13 @@
       </p:sp>
       <p:sp>
         <p:nvSpPr>
-          <p:cNvPr id="29" name="Text 27"/>
+          <p:cNvPr id="33" name="Text 31"/>
           <p:cNvSpPr txBox="1"/>
           <p:nvPr/>
         </p:nvSpPr>
         <p:spPr>
           <a:xfrm>
-            <a:off x="4462272" y="3456432"/>
+            <a:off x="4462272" y="3639312"/>
             <a:ext cx="1444752" cy="822960"/>
           </a:xfrm>
           <a:prstGeom prst="rect">
@@ -3386,13 +3494,13 @@
       </p:sp>
       <p:sp>
         <p:nvSpPr>
-          <p:cNvPr id="30" name="Dokumen PR"/>
+          <p:cNvPr id="34" name="Dokumen PR"/>
           <p:cNvSpPr/>
           <p:nvPr/>
         </p:nvSpPr>
         <p:spPr>
           <a:xfrm>
-            <a:off x="4800600" y="4416552"/>
+            <a:off x="4800600" y="4599432"/>
             <a:ext cx="768096" cy="310896"/>
           </a:xfrm>
           <a:prstGeom prst="roundRect">
@@ -3413,13 +3521,13 @@
       </p:sp>
       <p:sp>
         <p:nvSpPr>
-          <p:cNvPr id="31" name="Text 29"/>
+          <p:cNvPr id="35" name="Text 33"/>
           <p:cNvSpPr txBox="1"/>
           <p:nvPr/>
         </p:nvSpPr>
         <p:spPr>
           <a:xfrm>
-            <a:off x="4800600" y="4416552"/>
+            <a:off x="4800600" y="4599432"/>
             <a:ext cx="768096" cy="310896"/>
           </a:xfrm>
           <a:prstGeom prst="rect">
@@ -3449,13 +3557,13 @@
       </p:sp>
       <p:sp>
         <p:nvSpPr>
-          <p:cNvPr id="32" name="Panah cabang"/>
+          <p:cNvPr id="36" name="Panah cabang"/>
           <p:cNvSpPr/>
           <p:nvPr/>
         </p:nvSpPr>
         <p:spPr>
           <a:xfrm>
-            <a:off x="6025896" y="3863340"/>
+            <a:off x="6025896" y="4046220"/>
             <a:ext cx="160020" cy="0"/>
           </a:xfrm>
           <a:prstGeom prst="line">
@@ -3473,13 +3581,13 @@
       </p:sp>
       <p:sp>
         <p:nvSpPr>
-          <p:cNvPr id="33" name="Cabang Pesanan ke vendor"/>
+          <p:cNvPr id="37" name="Cabang Pesanan ke vendor"/>
           <p:cNvSpPr/>
           <p:nvPr/>
         </p:nvSpPr>
         <p:spPr>
           <a:xfrm>
-            <a:off x="6213348" y="3383280"/>
+            <a:off x="6213348" y="3566160"/>
             <a:ext cx="1627632" cy="960120"/>
           </a:xfrm>
           <a:prstGeom prst="roundRect">
@@ -3507,13 +3615,13 @@
       </p:sp>
       <p:sp>
         <p:nvSpPr>
-          <p:cNvPr id="34" name="Text 32"/>
+          <p:cNvPr id="38" name="Text 36"/>
           <p:cNvSpPr txBox="1"/>
           <p:nvPr/>
         </p:nvSpPr>
         <p:spPr>
           <a:xfrm>
-            <a:off x="6304788" y="3456432"/>
+            <a:off x="6304788" y="3639312"/>
             <a:ext cx="1444752" cy="822960"/>
           </a:xfrm>
           <a:prstGeom prst="rect">
@@ -3557,13 +3665,13 @@
       </p:sp>
       <p:sp>
         <p:nvSpPr>
-          <p:cNvPr id="35" name="Dokumen PO"/>
+          <p:cNvPr id="39" name="Dokumen PO"/>
           <p:cNvSpPr/>
           <p:nvPr/>
         </p:nvSpPr>
         <p:spPr>
           <a:xfrm>
-            <a:off x="6643116" y="4416552"/>
+            <a:off x="6643116" y="4599432"/>
             <a:ext cx="768096" cy="310896"/>
           </a:xfrm>
           <a:prstGeom prst="roundRect">
@@ -3584,13 +3692,13 @@
       </p:sp>
       <p:sp>
         <p:nvSpPr>
-          <p:cNvPr id="36" name="Text 34"/>
+          <p:cNvPr id="40" name="Text 38"/>
           <p:cNvSpPr txBox="1"/>
           <p:nvPr/>
         </p:nvSpPr>
         <p:spPr>
           <a:xfrm>
-            <a:off x="6643116" y="4416552"/>
+            <a:off x="6643116" y="4599432"/>
             <a:ext cx="768096" cy="310896"/>
           </a:xfrm>
           <a:prstGeom prst="rect">
@@ -3620,13 +3728,13 @@
       </p:sp>
       <p:sp>
         <p:nvSpPr>
-          <p:cNvPr id="37" name="Panah cabang"/>
+          <p:cNvPr id="41" name="Panah cabang"/>
           <p:cNvSpPr/>
           <p:nvPr/>
         </p:nvSpPr>
         <p:spPr>
           <a:xfrm>
-            <a:off x="7868412" y="3863340"/>
+            <a:off x="7868412" y="4046220"/>
             <a:ext cx="160020" cy="0"/>
           </a:xfrm>
           <a:prstGeom prst="line">
@@ -3644,13 +3752,13 @@
       </p:sp>
       <p:sp>
         <p:nvSpPr>
-          <p:cNvPr id="38" name="Cabang Barang vendor tiba"/>
+          <p:cNvPr id="42" name="Cabang Barang vendor tiba"/>
           <p:cNvSpPr/>
           <p:nvPr/>
         </p:nvSpPr>
         <p:spPr>
           <a:xfrm>
-            <a:off x="8055864" y="3383280"/>
+            <a:off x="8055864" y="3566160"/>
             <a:ext cx="1627632" cy="960120"/>
           </a:xfrm>
           <a:prstGeom prst="roundRect">
@@ -3678,13 +3786,13 @@
       </p:sp>
       <p:sp>
         <p:nvSpPr>
-          <p:cNvPr id="39" name="Text 37"/>
+          <p:cNvPr id="43" name="Text 41"/>
           <p:cNvSpPr txBox="1"/>
           <p:nvPr/>
         </p:nvSpPr>
         <p:spPr>
           <a:xfrm>
-            <a:off x="8147304" y="3456432"/>
+            <a:off x="8147304" y="3639312"/>
             <a:ext cx="1444752" cy="822960"/>
           </a:xfrm>
           <a:prstGeom prst="rect">
@@ -3728,13 +3836,13 @@
       </p:sp>
       <p:sp>
         <p:nvSpPr>
-          <p:cNvPr id="40" name="Dokumen GRPO"/>
+          <p:cNvPr id="44" name="Dokumen GRPO"/>
           <p:cNvSpPr/>
           <p:nvPr/>
         </p:nvSpPr>
         <p:spPr>
           <a:xfrm>
-            <a:off x="8485632" y="4416552"/>
+            <a:off x="8485632" y="4599432"/>
             <a:ext cx="768096" cy="310896"/>
           </a:xfrm>
           <a:prstGeom prst="roundRect">
@@ -3755,13 +3863,13 @@
       </p:sp>
       <p:sp>
         <p:nvSpPr>
-          <p:cNvPr id="41" name="Text 39"/>
+          <p:cNvPr id="45" name="Text 43"/>
           <p:cNvSpPr txBox="1"/>
           <p:nvPr/>
         </p:nvSpPr>
         <p:spPr>
           <a:xfrm>
-            <a:off x="8485632" y="4416552"/>
+            <a:off x="8485632" y="4599432"/>
             <a:ext cx="768096" cy="310896"/>
           </a:xfrm>
           <a:prstGeom prst="rect">
@@ -3791,14 +3899,14 @@
       </p:sp>
       <p:sp>
         <p:nvSpPr>
-          <p:cNvPr id="42" name="Kembali ke transfer"/>
+          <p:cNvPr id="46" name="Kembali ke transfer"/>
           <p:cNvSpPr/>
           <p:nvPr/>
         </p:nvSpPr>
         <p:spPr>
           <a:xfrm>
-            <a:off x="7027164" y="3172968"/>
-            <a:ext cx="1842516" cy="210312"/>
+            <a:off x="7027164" y="3401568"/>
+            <a:ext cx="1842516" cy="164592"/>
           </a:xfrm>
           <a:prstGeom prst="line">
             <a:avLst/>
@@ -3815,18 +3923,18 @@
       </p:sp>
       <p:sp>
         <p:nvSpPr>
-          <p:cNvPr id="43" name="Keterangan dokumen SAP"/>
+          <p:cNvPr id="47" name="Keterangan dokumen SAP"/>
           <p:cNvSpPr/>
           <p:nvPr/>
         </p:nvSpPr>
         <p:spPr>
           <a:xfrm>
-            <a:off x="1600200" y="4892040"/>
-            <a:ext cx="9921240" cy="1188720"/>
+            <a:off x="1600200" y="5010912"/>
+            <a:ext cx="9921240" cy="1097280"/>
           </a:xfrm>
           <a:prstGeom prst="roundRect">
             <a:avLst>
-              <a:gd name="adj" fmla="val 9231"/>
+              <a:gd name="adj" fmla="val 10000"/>
             </a:avLst>
           </a:prstGeom>
           <a:solidFill>
@@ -3849,13 +3957,13 @@
       </p:sp>
       <p:sp>
         <p:nvSpPr>
-          <p:cNvPr id="44" name="Text 42"/>
+          <p:cNvPr id="48" name="Text 46"/>
           <p:cNvSpPr txBox="1"/>
           <p:nvPr/>
         </p:nvSpPr>
         <p:spPr>
           <a:xfrm>
-            <a:off x="1828800" y="4965192"/>
+            <a:off x="1828800" y="5056632"/>
             <a:ext cx="5486400" cy="274320"/>
           </a:xfrm>
           <a:prstGeom prst="rect">
@@ -3885,13 +3993,13 @@
       </p:sp>
       <p:sp>
         <p:nvSpPr>
-          <p:cNvPr id="45" name="Keterangan SO"/>
+          <p:cNvPr id="49" name="Keterangan SO"/>
           <p:cNvSpPr/>
           <p:nvPr/>
         </p:nvSpPr>
         <p:spPr>
           <a:xfrm>
-            <a:off x="1828800" y="5303520"/>
+            <a:off x="1828800" y="5376672"/>
             <a:ext cx="658368" cy="274320"/>
           </a:xfrm>
           <a:prstGeom prst="roundRect">
@@ -3912,13 +4020,13 @@
       </p:sp>
       <p:sp>
         <p:nvSpPr>
-          <p:cNvPr id="46" name="Text 44"/>
+          <p:cNvPr id="50" name="Text 48"/>
           <p:cNvSpPr txBox="1"/>
           <p:nvPr/>
         </p:nvSpPr>
         <p:spPr>
           <a:xfrm>
-            <a:off x="1828800" y="5303520"/>
+            <a:off x="1828800" y="5376672"/>
             <a:ext cx="658368" cy="274320"/>
           </a:xfrm>
           <a:prstGeom prst="rect">
@@ -3948,13 +4056,13 @@
       </p:sp>
       <p:sp>
         <p:nvSpPr>
-          <p:cNvPr id="47" name="Text 45"/>
+          <p:cNvPr id="51" name="Text 49"/>
           <p:cNvSpPr txBox="1"/>
           <p:nvPr/>
         </p:nvSpPr>
         <p:spPr>
           <a:xfrm>
-            <a:off x="2578608" y="5285232"/>
+            <a:off x="2578608" y="5358384"/>
             <a:ext cx="2423160" cy="310896"/>
           </a:xfrm>
           <a:prstGeom prst="rect">
@@ -3995,13 +4103,13 @@
       </p:sp>
       <p:sp>
         <p:nvSpPr>
-          <p:cNvPr id="48" name="Keterangan PR"/>
+          <p:cNvPr id="52" name="Keterangan PR"/>
           <p:cNvSpPr/>
           <p:nvPr/>
         </p:nvSpPr>
         <p:spPr>
           <a:xfrm>
-            <a:off x="5074920" y="5303520"/>
+            <a:off x="5074920" y="5376672"/>
             <a:ext cx="658368" cy="274320"/>
           </a:xfrm>
           <a:prstGeom prst="roundRect">
@@ -4022,13 +4130,13 @@
       </p:sp>
       <p:sp>
         <p:nvSpPr>
-          <p:cNvPr id="49" name="Text 47"/>
+          <p:cNvPr id="53" name="Text 51"/>
           <p:cNvSpPr txBox="1"/>
           <p:nvPr/>
         </p:nvSpPr>
         <p:spPr>
           <a:xfrm>
-            <a:off x="5074920" y="5303520"/>
+            <a:off x="5074920" y="5376672"/>
             <a:ext cx="658368" cy="274320"/>
           </a:xfrm>
           <a:prstGeom prst="rect">
@@ -4058,13 +4166,13 @@
       </p:sp>
       <p:sp>
         <p:nvSpPr>
-          <p:cNvPr id="50" name="Text 48"/>
+          <p:cNvPr id="54" name="Text 52"/>
           <p:cNvSpPr txBox="1"/>
           <p:nvPr/>
         </p:nvSpPr>
         <p:spPr>
           <a:xfrm>
-            <a:off x="5824728" y="5285232"/>
+            <a:off x="5824728" y="5358384"/>
             <a:ext cx="2423160" cy="310896"/>
           </a:xfrm>
           <a:prstGeom prst="rect">
@@ -4105,13 +4213,13 @@
       </p:sp>
       <p:sp>
         <p:nvSpPr>
-          <p:cNvPr id="51" name="Keterangan PO"/>
+          <p:cNvPr id="55" name="Keterangan PO"/>
           <p:cNvSpPr/>
           <p:nvPr/>
         </p:nvSpPr>
         <p:spPr>
           <a:xfrm>
-            <a:off x="8321040" y="5303520"/>
+            <a:off x="8321040" y="5376672"/>
             <a:ext cx="658368" cy="274320"/>
           </a:xfrm>
           <a:prstGeom prst="roundRect">
@@ -4132,13 +4240,13 @@
       </p:sp>
       <p:sp>
         <p:nvSpPr>
-          <p:cNvPr id="52" name="Text 50"/>
+          <p:cNvPr id="56" name="Text 54"/>
           <p:cNvSpPr txBox="1"/>
           <p:nvPr/>
         </p:nvSpPr>
         <p:spPr>
           <a:xfrm>
-            <a:off x="8321040" y="5303520"/>
+            <a:off x="8321040" y="5376672"/>
             <a:ext cx="658368" cy="274320"/>
           </a:xfrm>
           <a:prstGeom prst="rect">
@@ -4168,13 +4276,13 @@
       </p:sp>
       <p:sp>
         <p:nvSpPr>
-          <p:cNvPr id="53" name="Text 51"/>
+          <p:cNvPr id="57" name="Text 55"/>
           <p:cNvSpPr txBox="1"/>
           <p:nvPr/>
         </p:nvSpPr>
         <p:spPr>
           <a:xfrm>
-            <a:off x="9070848" y="5285232"/>
+            <a:off x="9070848" y="5358384"/>
             <a:ext cx="2423160" cy="310896"/>
           </a:xfrm>
           <a:prstGeom prst="rect">
@@ -4215,13 +4323,13 @@
       </p:sp>
       <p:sp>
         <p:nvSpPr>
-          <p:cNvPr id="54" name="Keterangan GRPO"/>
+          <p:cNvPr id="58" name="Keterangan GRPO"/>
           <p:cNvSpPr/>
           <p:nvPr/>
         </p:nvSpPr>
         <p:spPr>
           <a:xfrm>
-            <a:off x="1828800" y="5669280"/>
+            <a:off x="1828800" y="5724144"/>
             <a:ext cx="658368" cy="274320"/>
           </a:xfrm>
           <a:prstGeom prst="roundRect">
@@ -4242,13 +4350,13 @@
       </p:sp>
       <p:sp>
         <p:nvSpPr>
-          <p:cNvPr id="55" name="Text 53"/>
+          <p:cNvPr id="59" name="Text 57"/>
           <p:cNvSpPr txBox="1"/>
           <p:nvPr/>
         </p:nvSpPr>
         <p:spPr>
           <a:xfrm>
-            <a:off x="1828800" y="5669280"/>
+            <a:off x="1828800" y="5724144"/>
             <a:ext cx="658368" cy="274320"/>
           </a:xfrm>
           <a:prstGeom prst="rect">
@@ -4278,13 +4386,13 @@
       </p:sp>
       <p:sp>
         <p:nvSpPr>
-          <p:cNvPr id="56" name="Text 54"/>
+          <p:cNvPr id="60" name="Text 58"/>
           <p:cNvSpPr txBox="1"/>
           <p:nvPr/>
         </p:nvSpPr>
         <p:spPr>
           <a:xfrm>
-            <a:off x="2578608" y="5650992"/>
+            <a:off x="2578608" y="5705856"/>
             <a:ext cx="2423160" cy="310896"/>
           </a:xfrm>
           <a:prstGeom prst="rect">
@@ -4325,13 +4433,13 @@
       </p:sp>
       <p:sp>
         <p:nvSpPr>
-          <p:cNvPr id="57" name="Keterangan IT"/>
+          <p:cNvPr id="61" name="Keterangan IT"/>
           <p:cNvSpPr/>
           <p:nvPr/>
         </p:nvSpPr>
         <p:spPr>
           <a:xfrm>
-            <a:off x="5074920" y="5669280"/>
+            <a:off x="5074920" y="5724144"/>
             <a:ext cx="658368" cy="274320"/>
           </a:xfrm>
           <a:prstGeom prst="roundRect">
@@ -4352,13 +4460,13 @@
       </p:sp>
       <p:sp>
         <p:nvSpPr>
-          <p:cNvPr id="58" name="Text 56"/>
+          <p:cNvPr id="62" name="Text 60"/>
           <p:cNvSpPr txBox="1"/>
           <p:nvPr/>
         </p:nvSpPr>
         <p:spPr>
           <a:xfrm>
-            <a:off x="5074920" y="5669280"/>
+            <a:off x="5074920" y="5724144"/>
             <a:ext cx="658368" cy="274320"/>
           </a:xfrm>
           <a:prstGeom prst="rect">
@@ -4388,13 +4496,13 @@
       </p:sp>
       <p:sp>
         <p:nvSpPr>
-          <p:cNvPr id="59" name="Text 57"/>
+          <p:cNvPr id="63" name="Text 61"/>
           <p:cNvSpPr txBox="1"/>
           <p:nvPr/>
         </p:nvSpPr>
         <p:spPr>
           <a:xfrm>
-            <a:off x="5824728" y="5650992"/>
+            <a:off x="5824728" y="5705856"/>
             <a:ext cx="2423160" cy="310896"/>
           </a:xfrm>
           <a:prstGeom prst="rect">
@@ -4435,13 +4543,13 @@
       </p:sp>
       <p:sp>
         <p:nvSpPr>
-          <p:cNvPr id="60" name="Keterangan DO"/>
+          <p:cNvPr id="64" name="Keterangan DO"/>
           <p:cNvSpPr/>
           <p:nvPr/>
         </p:nvSpPr>
         <p:spPr>
           <a:xfrm>
-            <a:off x="8321040" y="5669280"/>
+            <a:off x="8321040" y="5724144"/>
             <a:ext cx="658368" cy="274320"/>
           </a:xfrm>
           <a:prstGeom prst="roundRect">
@@ -4462,13 +4570,13 @@
       </p:sp>
       <p:sp>
         <p:nvSpPr>
-          <p:cNvPr id="61" name="Text 59"/>
+          <p:cNvPr id="65" name="Text 63"/>
           <p:cNvSpPr txBox="1"/>
           <p:nvPr/>
         </p:nvSpPr>
         <p:spPr>
           <a:xfrm>
-            <a:off x="8321040" y="5669280"/>
+            <a:off x="8321040" y="5724144"/>
             <a:ext cx="658368" cy="274320"/>
           </a:xfrm>
           <a:prstGeom prst="rect">
@@ -4498,13 +4606,13 @@
       </p:sp>
       <p:sp>
         <p:nvSpPr>
-          <p:cNvPr id="62" name="Text 60"/>
+          <p:cNvPr id="66" name="Text 64"/>
           <p:cNvSpPr txBox="1"/>
           <p:nvPr/>
         </p:nvSpPr>
         <p:spPr>
           <a:xfrm>
-            <a:off x="9070848" y="5650992"/>
+            <a:off x="9070848" y="5705856"/>
             <a:ext cx="2423160" cy="310896"/>
           </a:xfrm>
           <a:prstGeom prst="rect">

</xml_diff>

<commit_message>
Deck direksi: nama peran kantor pusat dengan unitnya (P2, Pergudangan, Purchasing)
Co-Authored-By: Claude Opus 5.5 <noreply@anthropic.com>
Claude-Session: https://claude.ai/code/session_01JEY5regGSA4jYBqyTUCMow
</commit_message>
<xml_diff>
--- a/docs/PID_POS_Paparan_Direksi_Template.pptx
+++ b/docs/PID_POS_Paparan_Direksi_Template.pptx
@@ -114,12 +114,12 @@
   <p:extLst>
     <p:ext uri="{521415D9-36F7-43E2-AB2F-B90AF26B5E84}">
       <p14:sectionLst xmlns:p14="http://schemas.microsoft.com/office/powerpoint/2010/main">
-        <p14:section name="Pembuka" id="{86ca8375-290a-8062-43fb-ed5261ac01e7}">
+        <p14:section name="Pembuka" id="{c3eca243-7ebd-c818-b2b2-69d500d93374}">
           <p14:sldIdLst>
             <p14:sldId id="256"/>
           </p14:sldIdLst>
         </p14:section>
-        <p14:section name="Aplikasi" id="{2f4358db-82f4-41cf-d742-1083ca4d9d6c}">
+        <p14:section name="Aplikasi" id="{f11659e3-837c-0d00-f8fc-5c11018d32f5}">
           <p14:sldIdLst>
             <p14:sldId id="257"/>
             <p14:sldId id="258"/>
@@ -129,7 +129,7 @@
             <p14:sldId id="262"/>
           </p14:sldIdLst>
         </p14:section>
-        <p14:section name="Penutup" id="{b7941551-9dec-0452-cd03-b16037ab2d8d}">
+        <p14:section name="Penutup" id="{5ec5b453-4623-ff72-ca20-542be846eae2}">
           <p14:sldIdLst>
             <p14:sldId id="263"/>
           </p14:sldIdLst>
@@ -802,7 +802,7 @@
           <a:p>
             <a:r>
               <a:rPr lang="en-US" dirty="0"/>
-              <a:t>Ada tujuh peran. Di kapal: admin kapal atau kepala toko, dan kasir. Di kantor pusat: Approve Sales Order, Approve Purchase Request, Admin Purchase, dan Approve Purchase Order. Di DC: admin DC. Setiap peran hanya melihat tugas yang menunggunya, lewat lonceng dan tab Giliran saya.</a:t>
+              <a:t>Ada tujuh peran. Di kapal: admin kapal atau kepala toko, dan kasir. Di kantor pusat: Approve SO oleh P2, Approve PUR oleh Pergudangan, serta Approve PO dan Admin PO oleh Purchasing. Di DC: admin DC. Setiap peran hanya melihat tugas yang menunggunya, lewat lonceng dan tab Giliran saya.</a:t>
             </a:r>
             <a:endParaRPr lang="en-US" dirty="0"/>
           </a:p>
@@ -2613,7 +2613,7 @@
                   <a:srgbClr val="5B6B86"/>
                 </a:solidFill>
               </a:rPr>
-              <a:t>Kantor pusat</a:t>
+              <a:t>Kantor pusat · P2</a:t>
             </a:r>
             <a:endParaRPr lang="en-US" sz="1500" dirty="0"/>
           </a:p>
@@ -3486,7 +3486,7 @@
                   <a:srgbClr val="5B6B86"/>
                 </a:solidFill>
               </a:rPr>
-              <a:t>Kantor pusat</a:t>
+              <a:t>Pergudangan</a:t>
             </a:r>
             <a:endParaRPr lang="en-US" sz="1400" dirty="0"/>
           </a:p>
@@ -5167,7 +5167,7 @@
       </p:sp>
       <p:sp>
         <p:nvSpPr>
-          <p:cNvPr id="15" name="Peran Approve Sales Order"/>
+          <p:cNvPr id="15" name="Peran Approve SO (P2)"/>
           <p:cNvSpPr/>
           <p:nvPr/>
         </p:nvSpPr>
@@ -5229,7 +5229,7 @@
                   <a:srgbClr val="274289"/>
                 </a:solidFill>
               </a:rPr>
-              <a:t>Approve Sales Order</a:t>
+              <a:t>Approve SO (P2)</a:t>
             </a:r>
             <a:endParaRPr lang="en-US" sz="1500" dirty="0"/>
           </a:p>
@@ -5243,7 +5243,7 @@
                   <a:srgbClr val="5B6B86"/>
                 </a:solidFill>
               </a:rPr>
-              <a:t>Setujui permintaan kapal ke DC</a:t>
+              <a:t>Setujui permintaan kapal jadi Sales Order</a:t>
             </a:r>
             <a:endParaRPr lang="en-US" sz="1500" dirty="0"/>
           </a:p>
@@ -5251,7 +5251,7 @@
       </p:sp>
       <p:sp>
         <p:nvSpPr>
-          <p:cNvPr id="17" name="Peran Approve Purchase Request"/>
+          <p:cNvPr id="17" name="Peran Approve PUR (Pergudangan)"/>
           <p:cNvSpPr/>
           <p:nvPr/>
         </p:nvSpPr>
@@ -5313,7 +5313,7 @@
                   <a:srgbClr val="274289"/>
                 </a:solidFill>
               </a:rPr>
-              <a:t>Approve Purchase Request</a:t>
+              <a:t>Approve PUR (Pergudangan)</a:t>
             </a:r>
             <a:endParaRPr lang="en-US" sz="1500" dirty="0"/>
           </a:p>
@@ -5327,7 +5327,7 @@
                   <a:srgbClr val="5B6B86"/>
                 </a:solidFill>
               </a:rPr>
-              <a:t>Setujui pembelian, penerimaan, transfer</a:t>
+              <a:t>Setujui Purchase Request, penerimaan, transfer</a:t>
             </a:r>
             <a:endParaRPr lang="en-US" sz="1500" dirty="0"/>
           </a:p>
@@ -5335,7 +5335,7 @@
       </p:sp>
       <p:sp>
         <p:nvSpPr>
-          <p:cNvPr id="19" name="Peran Admin Purchase"/>
+          <p:cNvPr id="19" name="Peran Approve PO (Purchasing)"/>
           <p:cNvSpPr/>
           <p:nvPr/>
         </p:nvSpPr>
@@ -5397,7 +5397,7 @@
                   <a:srgbClr val="274289"/>
                 </a:solidFill>
               </a:rPr>
-              <a:t>Admin Purchase</a:t>
+              <a:t>Approve PO (Purchasing)</a:t>
             </a:r>
             <a:endParaRPr lang="en-US" sz="1500" dirty="0"/>
           </a:p>
@@ -5411,7 +5411,7 @@
                   <a:srgbClr val="5B6B86"/>
                 </a:solidFill>
               </a:rPr>
-              <a:t>Buat Purchase Order ke vendor</a:t>
+              <a:t>Setujui Purchase Order ke vendor</a:t>
             </a:r>
             <a:endParaRPr lang="en-US" sz="1500" dirty="0"/>
           </a:p>
@@ -5419,7 +5419,7 @@
       </p:sp>
       <p:sp>
         <p:nvSpPr>
-          <p:cNvPr id="21" name="Peran Approve Purchase Order"/>
+          <p:cNvPr id="21" name="Peran Admin PO (Purchasing)"/>
           <p:cNvSpPr/>
           <p:nvPr/>
         </p:nvSpPr>
@@ -5481,7 +5481,7 @@
                   <a:srgbClr val="274289"/>
                 </a:solidFill>
               </a:rPr>
-              <a:t>Approve Purchase Order</a:t>
+              <a:t>Admin PO (Purchasing)</a:t>
             </a:r>
             <a:endParaRPr lang="en-US" sz="1500" dirty="0"/>
           </a:p>
@@ -5495,7 +5495,7 @@
                   <a:srgbClr val="5B6B86"/>
                 </a:solidFill>
               </a:rPr>
-              <a:t>Setujui pesanan ke vendor</a:t>
+              <a:t>Buat Purchase Order ke vendor</a:t>
             </a:r>
             <a:endParaRPr lang="en-US" sz="1500" dirty="0"/>
           </a:p>

</xml_diff>

<commit_message>
Deck direksi: halaman batasan aplikasi (internet, kasir hanya Android)
Co-Authored-By: Claude Opus 5.5 <noreply@anthropic.com>
Claude-Session: https://claude.ai/code/session_01JEY5regGSA4jYBqyTUCMow
</commit_message>
<xml_diff>
--- a/docs/PID_POS_Paparan_Direksi_Template.pptx
+++ b/docs/PID_POS_Paparan_Direksi_Template.pptx
@@ -13,9 +13,10 @@
     <p:sldId id="261" r:id="rId7"/>
     <p:sldId id="262" r:id="rId8"/>
     <p:sldId id="263" r:id="rId9"/>
+    <p:sldId id="264" r:id="rId10"/>
   </p:sldIdLst>
   <p:notesMasterIdLst>
-    <p:notesMasterId r:id="rId10"/>
+    <p:notesMasterId r:id="rId11"/>
   </p:notesMasterIdLst>
   <p:sldSz cx="12192000" cy="6858000"/>
   <p:notesSz cx="6858000" cy="12192000"/>
@@ -114,12 +115,12 @@
   <p:extLst>
     <p:ext uri="{521415D9-36F7-43E2-AB2F-B90AF26B5E84}">
       <p14:sectionLst xmlns:p14="http://schemas.microsoft.com/office/powerpoint/2010/main">
-        <p14:section name="Pembuka" id="{c3eca243-7ebd-c818-b2b2-69d500d93374}">
+        <p14:section name="Pembuka" id="{7ee4df1e-e647-c914-c2d0-95a46013e39a}">
           <p14:sldIdLst>
             <p14:sldId id="256"/>
           </p14:sldIdLst>
         </p14:section>
-        <p14:section name="Aplikasi" id="{f11659e3-837c-0d00-f8fc-5c11018d32f5}">
+        <p14:section name="Aplikasi" id="{80a5c0d5-7884-bc11-a976-b034a9a16899}">
           <p14:sldIdLst>
             <p14:sldId id="257"/>
             <p14:sldId id="258"/>
@@ -127,11 +128,12 @@
             <p14:sldId id="260"/>
             <p14:sldId id="261"/>
             <p14:sldId id="262"/>
+            <p14:sldId id="263"/>
           </p14:sldIdLst>
         </p14:section>
-        <p14:section name="Penutup" id="{5ec5b453-4623-ff72-ca20-542be846eae2}">
+        <p14:section name="Penutup" id="{e6694273-b787-15a7-be2e-19fd6a1cbab2}">
           <p14:sldIdLst>
-            <p14:sldId id="263"/>
+            <p14:sldId id="264"/>
           </p14:sldIdLst>
         </p14:section>
       </p14:sectionLst>
@@ -538,7 +540,7 @@
           <a:p>
             <a:r>
               <a:rPr lang="en-US" dirty="0"/>
-              <a:t>PID POS adalah aplikasi toko kapal PELNI Services yang terhubung langsung dengan SAP Business One. Paparan ini menyampaikan apa itu PID POS, alurnya, peran yang terlibat, fitur utama, kasir, dan keunggulannya.</a:t>
+              <a:t>PID POS adalah aplikasi toko kapal PELNI Services yang terhubung langsung dengan SAP Business One. Paparan ini menyampaikan apa itu PID POS, alurnya, peran yang terlibat, fitur utama, kasir, keunggulan, dan batasannya saat ini.</a:t>
             </a:r>
             <a:endParaRPr lang="en-US" dirty="0"/>
           </a:p>
@@ -1154,7 +1156,7 @@
           <a:p>
             <a:r>
               <a:rPr lang="en-US" dirty="0"/>
-              <a:t>PID POS: satu alur, dari kapal sampai kasir. Terima kasih.</a:t>
+              <a:t>Ada dua batasan PID POS saat ini. Pertama, aplikasi web dan kasir memerlukan koneksi internet, jadi kapal, DC, dan kantor pusat perlu terhubung saat aplikasi dipakai. Kedua, aplikasi kasir baru tersedia di Android; versi iOS untuk iPhone dan iPad belum tersedia, jadi perangkat kasir di setiap dek perlu memakai Android.</a:t>
             </a:r>
             <a:endParaRPr lang="en-US" dirty="0"/>
           </a:p>
@@ -1178,6 +1180,94 @@
             <a:fld id="{F7021451-1387-4CA6-816F-3879F97B5CBC}" type="slidenum">
               <a:rPr lang="en-US"/>
               <a:t>8</a:t>
+            </a:fld>
+            <a:endParaRPr lang="en-US"/>
+          </a:p>
+        </p:txBody>
+      </p:sp>
+    </p:spTree>
+    <p:extLst>
+      <p:ext uri="{BB962C8B-B14F-4D97-AF65-F5344CB8AC3E}">
+        <p14:creationId xmlns:p14="http://schemas.microsoft.com/office/powerpoint/2010/main" val="1024086991"/>
+      </p:ext>
+    </p:extLst>
+  </p:cSld>
+  <p:clrMapOvr>
+    <a:masterClrMapping/>
+  </p:clrMapOvr>
+</p:notes>
+</file>
+
+<file path=ppt/notesSlides/notesSlide9.xml><?xml version="1.0" encoding="utf-8"?>
+<p:notes xmlns:a="http://schemas.openxmlformats.org/drawingml/2006/main" xmlns:r="http://schemas.openxmlformats.org/officeDocument/2006/relationships" xmlns:p="http://schemas.openxmlformats.org/presentationml/2006/main">
+  <p:cSld>
+    <p:spTree>
+      <p:nvGrpSpPr>
+        <p:cNvPr id="1" name=""/>
+        <p:cNvGrpSpPr/>
+        <p:nvPr/>
+      </p:nvGrpSpPr>
+      <p:grpSpPr>
+        <a:xfrm>
+          <a:off x="0" y="0"/>
+          <a:ext cx="0" cy="0"/>
+          <a:chOff x="0" y="0"/>
+          <a:chExt cx="0" cy="0"/>
+        </a:xfrm>
+      </p:grpSpPr>
+      <p:sp>
+        <p:nvSpPr>
+          <p:cNvPr id="2" name="Slide Image Placeholder 1"/>
+          <p:cNvSpPr>
+            <a:spLocks noGrp="1" noRot="1" noChangeAspect="1"/>
+          </p:cNvSpPr>
+          <p:nvPr>
+            <p:ph type="sldImg"/>
+          </p:nvPr>
+        </p:nvSpPr>
+        <p:spPr/>
+      </p:sp>
+      <p:sp>
+        <p:nvSpPr>
+          <p:cNvPr id="3" name="Notes Placeholder 2"/>
+          <p:cNvSpPr>
+            <a:spLocks noGrp="1"/>
+          </p:cNvSpPr>
+          <p:nvPr>
+            <p:ph type="body" idx="1"/>
+          </p:nvPr>
+        </p:nvSpPr>
+        <p:spPr/>
+        <p:txBody>
+          <a:bodyPr/>
+          <a:lstStyle/>
+          <a:p>
+            <a:r>
+              <a:rPr lang="en-US" dirty="0"/>
+              <a:t>PID POS: satu alur, dari kapal sampai kasir. Terima kasih.</a:t>
+            </a:r>
+            <a:endParaRPr lang="en-US" dirty="0"/>
+          </a:p>
+        </p:txBody>
+      </p:sp>
+      <p:sp>
+        <p:nvSpPr>
+          <p:cNvPr id="4" name="Slide Number Placeholder 3"/>
+          <p:cNvSpPr>
+            <a:spLocks noGrp="1"/>
+          </p:cNvSpPr>
+          <p:nvPr>
+            <p:ph type="sldNum" sz="quarter" idx="10"/>
+          </p:nvPr>
+        </p:nvSpPr>
+        <p:spPr/>
+        <p:txBody>
+          <a:bodyPr/>
+          <a:lstStyle/>
+          <a:p>
+            <a:fld id="{F7021451-1387-4CA6-816F-3879F97B5CBC}" type="slidenum">
+              <a:rPr lang="en-US"/>
+              <a:t>9</a:t>
             </a:fld>
             <a:endParaRPr lang="en-US"/>
           </a:p>
@@ -7553,6 +7643,712 @@
 <file path=ppt/slides/slide8.xml><?xml version="1.0" encoding="utf-8"?>
 <p:sld xmlns:a="http://schemas.openxmlformats.org/drawingml/2006/main" xmlns:r="http://schemas.openxmlformats.org/officeDocument/2006/relationships" xmlns:p="http://schemas.openxmlformats.org/presentationml/2006/main">
   <p:cSld name="Slide 8">
+    <p:spTree>
+      <p:nvGrpSpPr>
+        <p:cNvPr id="1" name=""/>
+        <p:cNvGrpSpPr/>
+        <p:nvPr/>
+      </p:nvGrpSpPr>
+      <p:grpSpPr>
+        <a:xfrm>
+          <a:off x="0" y="0"/>
+          <a:ext cx="0" cy="0"/>
+          <a:chOff x="0" y="0"/>
+          <a:chExt cx="0" cy="0"/>
+        </a:xfrm>
+      </p:grpSpPr>
+      <p:sp>
+        <p:nvSpPr>
+          <p:cNvPr id="2" name="Text 0"/>
+          <p:cNvSpPr/>
+          <p:nvPr>
+            <p:ph idx="100" type="title" hasCustomPrompt="1"/>
+          </p:nvPr>
+        </p:nvSpPr>
+        <p:spPr>
+          <a:xfrm>
+            <a:off x="685800" y="914400"/>
+            <a:ext cx="10835640" cy="640080"/>
+          </a:xfrm>
+          <a:prstGeom prst="rect">
+            <a:avLst/>
+          </a:prstGeom>
+          <a:noFill/>
+          <a:ln/>
+        </p:spPr>
+        <p:txBody>
+          <a:bodyPr wrap="square" lIns="0" tIns="0" rIns="0" bIns="0" rtlCol="0" anchor="ctr"/>
+          <a:lstStyle/>
+          <a:p>
+            <a:pPr algn="l" indent="0" marL="0">
+              <a:buNone/>
+            </a:pPr>
+            <a:r>
+              <a:rPr lang="en-US" sz="3000" b="1" dirty="0">
+                <a:solidFill>
+                  <a:schemeClr val="tx2"/>
+                </a:solidFill>
+              </a:rPr>
+              <a:t>Batasan aplikasi saat ini</a:t>
+            </a:r>
+            <a:endParaRPr lang="en-US" sz="3000" dirty="0"/>
+          </a:p>
+        </p:txBody>
+      </p:sp>
+      <p:sp>
+        <p:nvSpPr>
+          <p:cNvPr id="3" name="Batasan Memerlukan koneksi internet"/>
+          <p:cNvSpPr/>
+          <p:nvPr/>
+        </p:nvSpPr>
+        <p:spPr>
+          <a:xfrm>
+            <a:off x="685800" y="1737360"/>
+            <a:ext cx="5303520" cy="3429000"/>
+          </a:xfrm>
+          <a:prstGeom prst="roundRect">
+            <a:avLst>
+              <a:gd name="adj" fmla="val 3200"/>
+            </a:avLst>
+          </a:prstGeom>
+          <a:solidFill>
+            <a:srgbClr val="FFFFFF"/>
+          </a:solidFill>
+          <a:ln w="9525">
+            <a:solidFill>
+              <a:srgbClr val="E3E9F3"/>
+            </a:solidFill>
+            <a:prstDash val="solid"/>
+          </a:ln>
+          <a:effectLst>
+            <a:outerShdw sx="100000" sy="100000" kx="0" ky="0" algn="bl" rotWithShape="0" blurRad="101600" dist="25400" dir="5400000">
+              <a:srgbClr val="274289">
+                <a:alpha val="12000"/>
+              </a:srgbClr>
+            </a:outerShdw>
+          </a:effectLst>
+        </p:spPr>
+      </p:sp>
+      <p:sp>
+        <p:nvSpPr>
+          <p:cNvPr id="4" name="Ikon Memerlukan koneksi internet latar"/>
+          <p:cNvSpPr/>
+          <p:nvPr/>
+        </p:nvSpPr>
+        <p:spPr>
+          <a:xfrm>
+            <a:off x="1005840" y="2011680"/>
+            <a:ext cx="868680" cy="868680"/>
+          </a:xfrm>
+          <a:prstGeom prst="ellipse">
+            <a:avLst/>
+          </a:prstGeom>
+          <a:solidFill>
+            <a:srgbClr val="274289"/>
+          </a:solidFill>
+          <a:ln w="12700">
+            <a:solidFill>
+              <a:srgbClr val="274289"/>
+            </a:solidFill>
+            <a:prstDash val="solid"/>
+          </a:ln>
+        </p:spPr>
+      </p:sp>
+      <p:pic>
+        <p:nvPicPr>
+          <p:cNvPr id="5" name="Ikon Memerlukan koneksi internet" descr="Ikon Memerlukan koneksi internet">    </p:cNvPr>
+          <p:cNvPicPr>
+            <a:picLocks noChangeAspect="1"/>
+          </p:cNvPicPr>
+          <p:nvPr/>
+        </p:nvPicPr>
+        <p:blipFill>
+          <a:blip r:embed="rId1"/>
+          <a:stretch>
+            <a:fillRect/>
+          </a:stretch>
+        </p:blipFill>
+        <p:spPr>
+          <a:xfrm>
+            <a:off x="1223010" y="2228850"/>
+            <a:ext cx="434340" cy="434340"/>
+          </a:xfrm>
+          <a:prstGeom prst="rect">
+            <a:avLst/>
+          </a:prstGeom>
+        </p:spPr>
+      </p:pic>
+      <p:sp>
+        <p:nvSpPr>
+          <p:cNvPr id="6" name="Text 3"/>
+          <p:cNvSpPr txBox="1"/>
+          <p:nvPr/>
+        </p:nvSpPr>
+        <p:spPr>
+          <a:xfrm>
+            <a:off x="1005840" y="3063240"/>
+            <a:ext cx="4663440" cy="502920"/>
+          </a:xfrm>
+          <a:prstGeom prst="rect">
+            <a:avLst/>
+          </a:prstGeom>
+          <a:noFill/>
+          <a:ln/>
+        </p:spPr>
+        <p:txBody>
+          <a:bodyPr wrap="square" lIns="0" tIns="0" rIns="0" bIns="0" rtlCol="0" anchor="t"/>
+          <a:lstStyle/>
+          <a:p>
+            <a:pPr indent="0" marL="0">
+              <a:buNone/>
+            </a:pPr>
+            <a:r>
+              <a:rPr lang="en-US" sz="2400" b="1" dirty="0">
+                <a:solidFill>
+                  <a:srgbClr val="274289"/>
+                </a:solidFill>
+              </a:rPr>
+              <a:t>Memerlukan koneksi internet</a:t>
+            </a:r>
+            <a:endParaRPr lang="en-US" sz="2400" dirty="0"/>
+          </a:p>
+        </p:txBody>
+      </p:sp>
+      <p:sp>
+        <p:nvSpPr>
+          <p:cNvPr id="7" name="Text 4"/>
+          <p:cNvSpPr txBox="1"/>
+          <p:nvPr/>
+        </p:nvSpPr>
+        <p:spPr>
+          <a:xfrm>
+            <a:off x="1005840" y="3611880"/>
+            <a:ext cx="4663440" cy="731520"/>
+          </a:xfrm>
+          <a:prstGeom prst="rect">
+            <a:avLst/>
+          </a:prstGeom>
+          <a:noFill/>
+          <a:ln/>
+        </p:spPr>
+        <p:txBody>
+          <a:bodyPr wrap="square" lIns="0" tIns="0" rIns="0" bIns="0" rtlCol="0" anchor="t"/>
+          <a:lstStyle/>
+          <a:p>
+            <a:pPr indent="0" marL="0">
+              <a:buNone/>
+            </a:pPr>
+            <a:r>
+              <a:rPr lang="en-US" sz="1500" dirty="0">
+                <a:solidFill>
+                  <a:srgbClr val="1B2437"/>
+                </a:solidFill>
+              </a:rPr>
+              <a:t>Aplikasi web dan aplikasi kasir hanya dapat digunakan saat perangkat terhubung ke internet.</a:t>
+            </a:r>
+            <a:endParaRPr lang="en-US" sz="1500" dirty="0"/>
+          </a:p>
+        </p:txBody>
+      </p:sp>
+      <p:sp>
+        <p:nvSpPr>
+          <p:cNvPr id="8" name="Pemisah"/>
+          <p:cNvSpPr/>
+          <p:nvPr/>
+        </p:nvSpPr>
+        <p:spPr>
+          <a:xfrm>
+            <a:off x="1005840" y="4434840"/>
+            <a:ext cx="4663440" cy="0"/>
+          </a:xfrm>
+          <a:prstGeom prst="line">
+            <a:avLst/>
+          </a:prstGeom>
+          <a:noFill/>
+          <a:ln w="12700">
+            <a:solidFill>
+              <a:srgbClr val="E3E9F3"/>
+            </a:solidFill>
+            <a:prstDash val="solid"/>
+          </a:ln>
+        </p:spPr>
+      </p:sp>
+      <p:sp>
+        <p:nvSpPr>
+          <p:cNvPr id="9" name="Text 6"/>
+          <p:cNvSpPr txBox="1"/>
+          <p:nvPr/>
+        </p:nvSpPr>
+        <p:spPr>
+          <a:xfrm>
+            <a:off x="1005840" y="4553712"/>
+            <a:ext cx="4663440" cy="457200"/>
+          </a:xfrm>
+          <a:prstGeom prst="rect">
+            <a:avLst/>
+          </a:prstGeom>
+          <a:noFill/>
+          <a:ln/>
+        </p:spPr>
+        <p:txBody>
+          <a:bodyPr wrap="square" lIns="0" tIns="0" rIns="0" bIns="0" rtlCol="0" anchor="t"/>
+          <a:lstStyle/>
+          <a:p>
+            <a:pPr indent="0" marL="0">
+              <a:buNone/>
+            </a:pPr>
+            <a:r>
+              <a:rPr lang="en-US" sz="1400" b="1" dirty="0">
+                <a:solidFill>
+                  <a:srgbClr val="274289"/>
+                </a:solidFill>
+              </a:rPr>
+              <a:t>Perlu disiapkan: </a:t>
+            </a:r>
+            <a:pPr indent="0" marL="0">
+              <a:buNone/>
+            </a:pPr>
+            <a:r>
+              <a:rPr lang="en-US" sz="1400" dirty="0">
+                <a:solidFill>
+                  <a:srgbClr val="1B2437"/>
+                </a:solidFill>
+              </a:rPr>
+              <a:t>Koneksi internet di kapal, DC, dan kantor pusat.</a:t>
+            </a:r>
+            <a:endParaRPr lang="en-US" sz="1400" dirty="0"/>
+          </a:p>
+        </p:txBody>
+      </p:sp>
+      <p:sp>
+        <p:nvSpPr>
+          <p:cNvPr id="10" name="Batasan Kasir hanya di Android"/>
+          <p:cNvSpPr/>
+          <p:nvPr/>
+        </p:nvSpPr>
+        <p:spPr>
+          <a:xfrm>
+            <a:off x="6217920" y="1737360"/>
+            <a:ext cx="5303520" cy="3429000"/>
+          </a:xfrm>
+          <a:prstGeom prst="roundRect">
+            <a:avLst>
+              <a:gd name="adj" fmla="val 3200"/>
+            </a:avLst>
+          </a:prstGeom>
+          <a:solidFill>
+            <a:srgbClr val="FFFFFF"/>
+          </a:solidFill>
+          <a:ln w="9525">
+            <a:solidFill>
+              <a:srgbClr val="E3E9F3"/>
+            </a:solidFill>
+            <a:prstDash val="solid"/>
+          </a:ln>
+          <a:effectLst>
+            <a:outerShdw sx="100000" sy="100000" kx="0" ky="0" algn="bl" rotWithShape="0" blurRad="101600" dist="25400" dir="5400000">
+              <a:srgbClr val="274289">
+                <a:alpha val="12000"/>
+              </a:srgbClr>
+            </a:outerShdw>
+          </a:effectLst>
+        </p:spPr>
+      </p:sp>
+      <p:sp>
+        <p:nvSpPr>
+          <p:cNvPr id="11" name="Ikon Kasir hanya di Android latar"/>
+          <p:cNvSpPr/>
+          <p:nvPr/>
+        </p:nvSpPr>
+        <p:spPr>
+          <a:xfrm>
+            <a:off x="6537960" y="2011680"/>
+            <a:ext cx="868680" cy="868680"/>
+          </a:xfrm>
+          <a:prstGeom prst="ellipse">
+            <a:avLst/>
+          </a:prstGeom>
+          <a:solidFill>
+            <a:srgbClr val="274289"/>
+          </a:solidFill>
+          <a:ln w="12700">
+            <a:solidFill>
+              <a:srgbClr val="274289"/>
+            </a:solidFill>
+            <a:prstDash val="solid"/>
+          </a:ln>
+        </p:spPr>
+      </p:sp>
+      <p:pic>
+        <p:nvPicPr>
+          <p:cNvPr id="12" name="Ikon Kasir hanya di Android" descr="Ikon Kasir hanya di Android">    </p:cNvPr>
+          <p:cNvPicPr>
+            <a:picLocks noChangeAspect="1"/>
+          </p:cNvPicPr>
+          <p:nvPr/>
+        </p:nvPicPr>
+        <p:blipFill>
+          <a:blip r:embed="rId2"/>
+          <a:stretch>
+            <a:fillRect/>
+          </a:stretch>
+        </p:blipFill>
+        <p:spPr>
+          <a:xfrm>
+            <a:off x="6755130" y="2228850"/>
+            <a:ext cx="434340" cy="434340"/>
+          </a:xfrm>
+          <a:prstGeom prst="rect">
+            <a:avLst/>
+          </a:prstGeom>
+        </p:spPr>
+      </p:pic>
+      <p:sp>
+        <p:nvSpPr>
+          <p:cNvPr id="13" name="Status Android"/>
+          <p:cNvSpPr/>
+          <p:nvPr/>
+        </p:nvSpPr>
+        <p:spPr>
+          <a:xfrm>
+            <a:off x="7680960" y="2258568"/>
+            <a:ext cx="1691640" cy="384048"/>
+          </a:xfrm>
+          <a:prstGeom prst="roundRect">
+            <a:avLst>
+              <a:gd name="adj" fmla="val 50000"/>
+            </a:avLst>
+          </a:prstGeom>
+          <a:solidFill>
+            <a:srgbClr val="E8F2E4"/>
+          </a:solidFill>
+          <a:ln w="12700">
+            <a:solidFill>
+              <a:srgbClr val="4A8A3C"/>
+            </a:solidFill>
+            <a:prstDash val="solid"/>
+          </a:ln>
+        </p:spPr>
+      </p:sp>
+      <p:sp>
+        <p:nvSpPr>
+          <p:cNvPr id="14" name="Text 10"/>
+          <p:cNvSpPr txBox="1"/>
+          <p:nvPr/>
+        </p:nvSpPr>
+        <p:spPr>
+          <a:xfrm>
+            <a:off x="7680960" y="2258568"/>
+            <a:ext cx="1691640" cy="384048"/>
+          </a:xfrm>
+          <a:prstGeom prst="rect">
+            <a:avLst/>
+          </a:prstGeom>
+          <a:noFill/>
+          <a:ln/>
+        </p:spPr>
+        <p:txBody>
+          <a:bodyPr wrap="square" lIns="0" tIns="0" rIns="0" bIns="0" rtlCol="0" anchor="ctr"/>
+          <a:lstStyle/>
+          <a:p>
+            <a:pPr algn="ctr" indent="0" marL="0">
+              <a:buNone/>
+            </a:pPr>
+            <a:r>
+              <a:rPr lang="en-US" sz="1200" b="1" dirty="0">
+                <a:solidFill>
+                  <a:srgbClr val="4A8A3C"/>
+                </a:solidFill>
+              </a:rPr>
+              <a:t>Android: </a:t>
+            </a:r>
+            <a:pPr algn="ctr" indent="0" marL="0">
+              <a:buNone/>
+            </a:pPr>
+            <a:r>
+              <a:rPr lang="en-US" sz="1200" dirty="0">
+                <a:solidFill>
+                  <a:srgbClr val="4A8A3C"/>
+                </a:solidFill>
+              </a:rPr>
+              <a:t>Tersedia</a:t>
+            </a:r>
+            <a:endParaRPr lang="en-US" sz="1200" dirty="0"/>
+          </a:p>
+        </p:txBody>
+      </p:sp>
+      <p:sp>
+        <p:nvSpPr>
+          <p:cNvPr id="15" name="Status iOS"/>
+          <p:cNvSpPr/>
+          <p:nvPr/>
+        </p:nvSpPr>
+        <p:spPr>
+          <a:xfrm>
+            <a:off x="9509760" y="2258568"/>
+            <a:ext cx="1691640" cy="384048"/>
+          </a:xfrm>
+          <a:prstGeom prst="roundRect">
+            <a:avLst>
+              <a:gd name="adj" fmla="val 50000"/>
+            </a:avLst>
+          </a:prstGeom>
+          <a:solidFill>
+            <a:srgbClr val="EEF1F6"/>
+          </a:solidFill>
+          <a:ln w="12700">
+            <a:solidFill>
+              <a:srgbClr val="5B6B86"/>
+            </a:solidFill>
+            <a:prstDash val="solid"/>
+          </a:ln>
+        </p:spPr>
+      </p:sp>
+      <p:sp>
+        <p:nvSpPr>
+          <p:cNvPr id="16" name="Text 12"/>
+          <p:cNvSpPr txBox="1"/>
+          <p:nvPr/>
+        </p:nvSpPr>
+        <p:spPr>
+          <a:xfrm>
+            <a:off x="9509760" y="2258568"/>
+            <a:ext cx="1691640" cy="384048"/>
+          </a:xfrm>
+          <a:prstGeom prst="rect">
+            <a:avLst/>
+          </a:prstGeom>
+          <a:noFill/>
+          <a:ln/>
+        </p:spPr>
+        <p:txBody>
+          <a:bodyPr wrap="square" lIns="0" tIns="0" rIns="0" bIns="0" rtlCol="0" anchor="ctr"/>
+          <a:lstStyle/>
+          <a:p>
+            <a:pPr algn="ctr" indent="0" marL="0">
+              <a:buNone/>
+            </a:pPr>
+            <a:r>
+              <a:rPr lang="en-US" sz="1200" b="1" dirty="0">
+                <a:solidFill>
+                  <a:srgbClr val="5B6B86"/>
+                </a:solidFill>
+              </a:rPr>
+              <a:t>iOS: </a:t>
+            </a:r>
+            <a:pPr algn="ctr" indent="0" marL="0">
+              <a:buNone/>
+            </a:pPr>
+            <a:r>
+              <a:rPr lang="en-US" sz="1200" dirty="0">
+                <a:solidFill>
+                  <a:srgbClr val="5B6B86"/>
+                </a:solidFill>
+              </a:rPr>
+              <a:t>Belum tersedia</a:t>
+            </a:r>
+            <a:endParaRPr lang="en-US" sz="1200" dirty="0"/>
+          </a:p>
+        </p:txBody>
+      </p:sp>
+      <p:sp>
+        <p:nvSpPr>
+          <p:cNvPr id="17" name="Text 13"/>
+          <p:cNvSpPr txBox="1"/>
+          <p:nvPr/>
+        </p:nvSpPr>
+        <p:spPr>
+          <a:xfrm>
+            <a:off x="6537960" y="3063240"/>
+            <a:ext cx="4663440" cy="502920"/>
+          </a:xfrm>
+          <a:prstGeom prst="rect">
+            <a:avLst/>
+          </a:prstGeom>
+          <a:noFill/>
+          <a:ln/>
+        </p:spPr>
+        <p:txBody>
+          <a:bodyPr wrap="square" lIns="0" tIns="0" rIns="0" bIns="0" rtlCol="0" anchor="t"/>
+          <a:lstStyle/>
+          <a:p>
+            <a:pPr indent="0" marL="0">
+              <a:buNone/>
+            </a:pPr>
+            <a:r>
+              <a:rPr lang="en-US" sz="2400" b="1" dirty="0">
+                <a:solidFill>
+                  <a:srgbClr val="274289"/>
+                </a:solidFill>
+              </a:rPr>
+              <a:t>Kasir hanya di Android</a:t>
+            </a:r>
+            <a:endParaRPr lang="en-US" sz="2400" dirty="0"/>
+          </a:p>
+        </p:txBody>
+      </p:sp>
+      <p:sp>
+        <p:nvSpPr>
+          <p:cNvPr id="18" name="Text 14"/>
+          <p:cNvSpPr txBox="1"/>
+          <p:nvPr/>
+        </p:nvSpPr>
+        <p:spPr>
+          <a:xfrm>
+            <a:off x="6537960" y="3611880"/>
+            <a:ext cx="4663440" cy="731520"/>
+          </a:xfrm>
+          <a:prstGeom prst="rect">
+            <a:avLst/>
+          </a:prstGeom>
+          <a:noFill/>
+          <a:ln/>
+        </p:spPr>
+        <p:txBody>
+          <a:bodyPr wrap="square" lIns="0" tIns="0" rIns="0" bIns="0" rtlCol="0" anchor="t"/>
+          <a:lstStyle/>
+          <a:p>
+            <a:pPr indent="0" marL="0">
+              <a:buNone/>
+            </a:pPr>
+            <a:r>
+              <a:rPr lang="en-US" sz="1500" dirty="0">
+                <a:solidFill>
+                  <a:srgbClr val="1B2437"/>
+                </a:solidFill>
+              </a:rPr>
+              <a:t>Aplikasi kasir baru tersedia untuk perangkat Android. Versi iOS (iPhone dan iPad) belum tersedia.</a:t>
+            </a:r>
+            <a:endParaRPr lang="en-US" sz="1500" dirty="0"/>
+          </a:p>
+        </p:txBody>
+      </p:sp>
+      <p:sp>
+        <p:nvSpPr>
+          <p:cNvPr id="19" name="Pemisah"/>
+          <p:cNvSpPr/>
+          <p:nvPr/>
+        </p:nvSpPr>
+        <p:spPr>
+          <a:xfrm>
+            <a:off x="6537960" y="4434840"/>
+            <a:ext cx="4663440" cy="0"/>
+          </a:xfrm>
+          <a:prstGeom prst="line">
+            <a:avLst/>
+          </a:prstGeom>
+          <a:noFill/>
+          <a:ln w="12700">
+            <a:solidFill>
+              <a:srgbClr val="E3E9F3"/>
+            </a:solidFill>
+            <a:prstDash val="solid"/>
+          </a:ln>
+        </p:spPr>
+      </p:sp>
+      <p:sp>
+        <p:nvSpPr>
+          <p:cNvPr id="20" name="Text 16"/>
+          <p:cNvSpPr txBox="1"/>
+          <p:nvPr/>
+        </p:nvSpPr>
+        <p:spPr>
+          <a:xfrm>
+            <a:off x="6537960" y="4553712"/>
+            <a:ext cx="4663440" cy="457200"/>
+          </a:xfrm>
+          <a:prstGeom prst="rect">
+            <a:avLst/>
+          </a:prstGeom>
+          <a:noFill/>
+          <a:ln/>
+        </p:spPr>
+        <p:txBody>
+          <a:bodyPr wrap="square" lIns="0" tIns="0" rIns="0" bIns="0" rtlCol="0" anchor="t"/>
+          <a:lstStyle/>
+          <a:p>
+            <a:pPr indent="0" marL="0">
+              <a:buNone/>
+            </a:pPr>
+            <a:r>
+              <a:rPr lang="en-US" sz="1400" b="1" dirty="0">
+                <a:solidFill>
+                  <a:srgbClr val="274289"/>
+                </a:solidFill>
+              </a:rPr>
+              <a:t>Perlu disiapkan: </a:t>
+            </a:r>
+            <a:pPr indent="0" marL="0">
+              <a:buNone/>
+            </a:pPr>
+            <a:r>
+              <a:rPr lang="en-US" sz="1400" dirty="0">
+                <a:solidFill>
+                  <a:srgbClr val="1B2437"/>
+                </a:solidFill>
+              </a:rPr>
+              <a:t>Perangkat kasir Android di setiap dek.</a:t>
+            </a:r>
+            <a:endParaRPr lang="en-US" sz="1400" dirty="0"/>
+          </a:p>
+        </p:txBody>
+      </p:sp>
+      <p:sp>
+        <p:nvSpPr>
+          <p:cNvPr id="25" name="Slide Number Placeholder 0"/>
+          <p:cNvSpPr>
+            <a:spLocks noGrp="1"/>
+          </p:cNvSpPr>
+          <p:nvPr>
+            <p:ph type="sldNum" sz="quarter" idx="4294967295"/>
+          </p:nvPr>
+        </p:nvSpPr>
+        <p:spPr>
+          <a:xfrm>
+            <a:off x="11109960" y="6309360"/>
+            <a:ext cx="457200" cy="274320"/>
+          </a:xfrm>
+          <a:prstGeom prst="rect">
+            <a:avLst/>
+          </a:prstGeom>
+          <a:extLst>
+            <a:ext uri="{C572A759-6A51-4108-AA02-DFA0A04FC94B}">
+              <ma14:wrappingTextBoxFlag xmlns:ma14="http://schemas.microsoft.com/office/mac/drawingml/2011/main" val="0"/>
+            </a:ext>
+          </a:extLst>
+        </p:spPr>
+        <p:txBody>
+          <a:bodyPr/>
+          <a:lstStyle>
+            <a:lvl1pPr>
+              <a:defRPr sz="1000">
+                <a:solidFill>
+                  <a:srgbClr val="5B6B86"/>
+                </a:solidFill>
+              </a:defRPr>
+            </a:lvl1pPr>
+          </a:lstStyle>
+          <a:p>
+            <a:pPr algn="r"/>
+            <a:fld id="{F7021451-1387-4CA6-816F-3879F97B5CBC}" type="slidenum">
+              <a:rPr b="0" lang="en-US"/>
+              <a:t>8</a:t>
+            </a:fld>
+            <a:endParaRPr lang="en-US"/>
+          </a:p>
+        </p:txBody>
+      </p:sp>
+    </p:spTree>
+  </p:cSld>
+  <p:clrMapOvr>
+    <a:masterClrMapping/>
+  </p:clrMapOvr>
+</p:sld>
+</file>
+
+<file path=ppt/slides/slide9.xml><?xml version="1.0" encoding="utf-8"?>
+<p:sld xmlns:a="http://schemas.openxmlformats.org/drawingml/2006/main" xmlns:r="http://schemas.openxmlformats.org/officeDocument/2006/relationships" xmlns:p="http://schemas.openxmlformats.org/presentationml/2006/main">
+  <p:cSld name="Slide 9">
     <p:spTree>
       <p:nvGrpSpPr>
         <p:cNvPr id="1" name=""/>

</xml_diff>

<commit_message>
Deck direksi: pelaksana persetujuan permintaan cukup P2
Co-Authored-By: Claude Opus 5.5 <noreply@anthropic.com>
Claude-Session: https://claude.ai/code/session_01JEY5regGSA4jYBqyTUCMow
</commit_message>
<xml_diff>
--- a/docs/PID_POS_Paparan_Direksi_Template.pptx
+++ b/docs/PID_POS_Paparan_Direksi_Template.pptx
@@ -115,12 +115,12 @@
   <p:extLst>
     <p:ext uri="{521415D9-36F7-43E2-AB2F-B90AF26B5E84}">
       <p14:sectionLst xmlns:p14="http://schemas.microsoft.com/office/powerpoint/2010/main">
-        <p14:section name="Pembuka" id="{7ee4df1e-e647-c914-c2d0-95a46013e39a}">
+        <p14:section name="Pembuka" id="{96fb3201-4978-8d16-3a11-36284e326262}">
           <p14:sldIdLst>
             <p14:sldId id="256"/>
           </p14:sldIdLst>
         </p14:section>
-        <p14:section name="Aplikasi" id="{80a5c0d5-7884-bc11-a976-b034a9a16899}">
+        <p14:section name="Aplikasi" id="{9ee130ed-1ceb-a369-bd01-e466063b909d}">
           <p14:sldIdLst>
             <p14:sldId id="257"/>
             <p14:sldId id="258"/>
@@ -131,7 +131,7 @@
             <p14:sldId id="263"/>
           </p14:sldIdLst>
         </p14:section>
-        <p14:section name="Penutup" id="{e6694273-b787-15a7-be2e-19fd6a1cbab2}">
+        <p14:section name="Penutup" id="{524fadb9-6fd0-7f79-9b59-98f4ca202548}">
           <p14:sldIdLst>
             <p14:sldId id="264"/>
           </p14:sldIdLst>
@@ -2703,7 +2703,7 @@
                   <a:srgbClr val="5B6B86"/>
                 </a:solidFill>
               </a:rPr>
-              <a:t>Kantor pusat · P2</a:t>
+              <a:t>P2</a:t>
             </a:r>
             <a:endParaRPr lang="en-US" sz="1500" dirty="0"/>
           </a:p>

</xml_diff>

<commit_message>
Deck direksi: naskah paparan lengkap di catatan pembicara dan dokumen terpisah
Co-Authored-By: Claude Opus 5.5 <noreply@anthropic.com>
Claude-Session: https://claude.ai/code/session_01JEY5regGSA4jYBqyTUCMow
</commit_message>
<xml_diff>
--- a/docs/PID_POS_Paparan_Direksi_Template.pptx
+++ b/docs/PID_POS_Paparan_Direksi_Template.pptx
@@ -115,12 +115,12 @@
   <p:extLst>
     <p:ext uri="{521415D9-36F7-43E2-AB2F-B90AF26B5E84}">
       <p14:sectionLst xmlns:p14="http://schemas.microsoft.com/office/powerpoint/2010/main">
-        <p14:section name="Pembuka" id="{96fb3201-4978-8d16-3a11-36284e326262}">
+        <p14:section name="Pembuka" id="{0790b8da-cc3c-1c64-1c1c-068236e312a5}">
           <p14:sldIdLst>
             <p14:sldId id="256"/>
           </p14:sldIdLst>
         </p14:section>
-        <p14:section name="Aplikasi" id="{9ee130ed-1ceb-a369-bd01-e466063b909d}">
+        <p14:section name="Aplikasi" id="{19147f7d-b5b3-ad0f-be31-39232a810ee6}">
           <p14:sldIdLst>
             <p14:sldId id="257"/>
             <p14:sldId id="258"/>
@@ -131,7 +131,7 @@
             <p14:sldId id="263"/>
           </p14:sldIdLst>
         </p14:section>
-        <p14:section name="Penutup" id="{524fadb9-6fd0-7f79-9b59-98f4ca202548}">
+        <p14:section name="Penutup" id="{d7a2e5e7-81a8-9de3-0302-88b271e37b9f}">
           <p14:sldIdLst>
             <p14:sldId id="264"/>
           </p14:sldIdLst>
@@ -540,7 +540,9 @@
           <a:p>
             <a:r>
               <a:rPr lang="en-US" dirty="0"/>
-              <a:t>PID POS adalah aplikasi toko kapal PELNI Services yang terhubung langsung dengan SAP Business One. Paparan ini menyampaikan apa itu PID POS, alurnya, peran yang terlibat, fitur utama, kasir, keunggulan, dan batasannya saat ini.</a:t>
+              <a:t>Selamat pagi, Bapak dan Ibu Direksi.
+Pada kesempatan ini kami memaparkan PID POS, aplikasi toko kapal PT Pelita Indonesia Djaya yang terhubung langsung dengan SAP Business One.
+Kami akan menyampaikan apa itu PID POS, bagaimana alurnya, siapa saja yang terlibat, fitur utamanya, kasir di setiap dek, keunggulan, dan batasannya saat ini.</a:t>
             </a:r>
             <a:endParaRPr lang="en-US" dirty="0"/>
           </a:p>
@@ -628,7 +630,10 @@
           <a:p>
             <a:r>
               <a:rPr lang="en-US" dirty="0"/>
-              <a:t>PID POS terdiri dari aplikasi web untuk admin kapal, Distribution Center atau DC, dan kantor pusat, serta aplikasi kasir Android untuk setiap dek. Keduanya terhubung langsung dengan SAP Business One, sehingga dokumen dibuat otomatis setelah disetujui.</a:t>
+              <a:t>PID POS terdiri dari dua bagian yang saling terhubung.
+Pertama, aplikasi web. Aplikasi ini dipakai oleh admin kapal, Distribution Center atau DC, dan kantor pusat untuk memesan barang, memberi persetujuan, memantau stok, dan melihat laporan.
+Kedua, aplikasi kasir Android untuk setiap dek. Kasir memindai barang, menerima pembayaran tunai atau QRIS, mencetak struk, dan menutup shift.
+Keduanya terhubung dengan SAP Business One. Setelah sebuah langkah disetujui, dokumennya dibuat otomatis di SAP, sehingga tidak ada lagi input ulang.</a:t>
             </a:r>
             <a:endParaRPr lang="en-US" dirty="0"/>
           </a:p>
@@ -716,7 +721,13 @@
           <a:p>
             <a:r>
               <a:rPr lang="en-US" dirty="0"/>
-              <a:t>Jalur atas selalu dijalani: kapal memesan ke DC, kantor pusat menyetujui sehingga Sales Order terbentuk di SAP, DC memilah stok, barang dikirim ke dek dengan Inventory Transfer, diterima kepala toko, lalu dijual di kasir dan masuk SAP sebagai Delivery Order. Bila stok DC kurang, jalur pembelian berjalan: Purchase Request, Purchase Order ke vendor, dan Goods Receipt PO (GRPO) saat barang tiba di DC. Alur ini berulang: setelah barang terjual dan stok dek menipis, kapal memesan lagi ke DC.</a:t>
+              <a:t>Halaman ini menunjukkan alur lengkapnya, dari pemesanan sampai penjualan.
+Jalur atas selalu dijalani. Admin kapal memesan barang ke DC. Permintaan itu disetujui oleh P2, lalu terbentuk Sales Order di SAP.
+Admin DC memilah stok dan mengirim barang ke dek. Pengiriman ini tercatat di SAP sebagai Inventory Transfer.
+Kepala toko menerima barang di dek, lalu barang dijual di kasir. Penjualan harian setiap dek masuk ke SAP sebagai Delivery Order.
+Bila stok di DC kurang, jalur pembelian di bawah berjalan. Pergudangan menyetujui Purchase Request, Purchasing membuat Purchase Order ke vendor, dan saat barang vendor tiba di DC, dicatat sebagai Goods Receipt PO atau GRPO. Setelah itu barang lanjut dikirim ke dek.
+Alur ini berulang. Ketika stok dek menipis, kapal memesan lagi ke DC.
+Enam jenis dokumen SAP pada kotak keterangan di bawah semuanya dibuat otomatis oleh aplikasi.</a:t>
             </a:r>
             <a:endParaRPr lang="en-US" dirty="0"/>
           </a:p>
@@ -804,7 +815,11 @@
           <a:p>
             <a:r>
               <a:rPr lang="en-US" dirty="0"/>
-              <a:t>Ada tujuh peran. Di kapal: admin kapal atau kepala toko, dan kasir. Di kantor pusat: Approve SO oleh P2, Approve PUR oleh Pergudangan, serta Approve PO dan Admin PO oleh Purchasing. Di DC: admin DC. Setiap peran hanya melihat tugas yang menunggunya, lewat lonceng dan tab Giliran saya.</a:t>
+              <a:t>Ada tujuh peran di PID POS.
+Di kapal ada admin kapal atau kepala toko, dan kasir.
+Di kantor pusat ada empat peran: Approve SO oleh P2, Approve PUR oleh Pergudangan, serta Approve PO dan Admin PO oleh Purchasing.
+Di DC ada admin DC.
+Setiap peran hanya melihat tugas yang sedang menunggunya, melalui lonceng notifikasi dan tab Giliran saya. Dengan begitu tidak ada pekerjaan yang terlewat.</a:t>
             </a:r>
             <a:endParaRPr lang="en-US" dirty="0"/>
           </a:p>
@@ -892,7 +907,10 @@
           <a:p>
             <a:r>
               <a:rPr lang="en-US" dirty="0"/>
-              <a:t>Tiga fitur utama aplikasi web: admin kapal memesan barang ke DC per dek; setiap permintaan disetujui berjenjang dan statusnya terlihat per tahap, lalu menjadi Sales Order di SAP; dan posisi stok setiap dek terpantau dalam satu tabel.</a:t>
+              <a:t>Ada tiga fitur utama di aplikasi web.
+Pertama, Pesan ke DC. Admin kapal memilih barang dan dek tujuan, lalu mengirim permintaan ke DC.
+Kedua, persetujuan berjenjang. Status setiap tahap terlihat jelas, dan setelah disetujui, permintaan otomatis menjadi Sales Order di SAP.
+Ketiga, posisi stok per dek. Stok setiap dek, totalnya, dan penjualan tujuh hari terakhir terlihat dalam satu tabel.</a:t>
             </a:r>
             <a:endParaRPr lang="en-US" dirty="0"/>
           </a:p>
@@ -980,7 +998,11 @@
           <a:p>
             <a:r>
               <a:rPr lang="en-US" dirty="0"/>
-              <a:t>Di setiap dek, kasir cukup scan barang, menerima pembayaran tunai atau QRIS dengan kembalian dihitung otomatis, lalu struk tercetak. Di akhir hari, penjualan dikirim ke SAP sebagai Delivery Order.</a:t>
+              <a:t>Di setiap dek, kasir bekerja dalam empat langkah sederhana.
+Scan barang dengan barcode, atau ketik nama atau kode barang.
+Terima pembayaran tunai atau QRIS. Kembalian dihitung otomatis.
+Struk tercetak, dan bisa dicetak ulang dari riwayat transaksi.
+Di akhir hari, penjualan dikirim ke SAP sebagai Delivery Order.</a:t>
             </a:r>
             <a:endParaRPr lang="en-US" dirty="0"/>
           </a:p>
@@ -1068,7 +1090,10 @@
           <a:p>
             <a:r>
               <a:rPr lang="en-US" dirty="0"/>
-              <a:t>Keunggulan PID POS ada tiga. Transparan: stok setiap dek dan status permintaan terpantau real-time. Terkendali: setiap tahap disetujui berjenjang, dan setiap persetujuan tercatat lengkap dengan siapa dan kapan. Terintegrasi: dokumen SAP dibuat otomatis, termasuk penjualan harian setiap dek sebagai Delivery Order.</a:t>
+              <a:t>Keunggulan PID POS dapat diringkas dalam tiga kata.
+Transparan. Stok setiap dek dan status setiap permintaan terpantau secara real-time, lengkap dengan riwayatnya.
+Terkendali. Setiap tahap melalui persetujuan berjenjang, dan setiap persetujuan tercatat lengkap: siapa yang menyetujui dan kapan.
+Terintegrasi. Dokumen SAP Business One dibuat otomatis, dan penjualan harian setiap dek masuk ke SAP sebagai Delivery Order.</a:t>
             </a:r>
             <a:endParaRPr lang="en-US" dirty="0"/>
           </a:p>
@@ -1156,7 +1181,9 @@
           <a:p>
             <a:r>
               <a:rPr lang="en-US" dirty="0"/>
-              <a:t>Ada dua batasan PID POS saat ini. Pertama, aplikasi web dan kasir memerlukan koneksi internet, jadi kapal, DC, dan kantor pusat perlu terhubung saat aplikasi dipakai. Kedua, aplikasi kasir baru tersedia di Android; versi iOS untuk iPhone dan iPad belum tersedia, jadi perangkat kasir di setiap dek perlu memakai Android.</a:t>
+              <a:t>Kami juga perlu menyampaikan dua batasan PID POS saat ini.
+Pertama, aplikasi memerlukan koneksi internet. Aplikasi web dan aplikasi kasir hanya dapat digunakan saat perangkat terhubung ke internet. Karena itu, koneksi internet di kapal, DC, dan kantor pusat perlu disiapkan.
+Kedua, aplikasi kasir baru tersedia di Android. Versi iOS untuk iPhone dan iPad belum tersedia, sehingga perangkat kasir di setiap dek perlu menggunakan Android.</a:t>
             </a:r>
             <a:endParaRPr lang="en-US" dirty="0"/>
           </a:p>
@@ -1244,7 +1271,8 @@
           <a:p>
             <a:r>
               <a:rPr lang="en-US" dirty="0"/>
-              <a:t>PID POS: satu alur, dari kapal sampai kasir. Terima kasih.</a:t>
+              <a:t>Demikian paparan kami. PID POS: satu alur, dari kapal sampai kasir.
+Terima kasih. Kami persilakan Bapak dan Ibu Direksi untuk memberikan arahan atau pertanyaan.</a:t>
             </a:r>
             <a:endParaRPr lang="en-US" dirty="0"/>
           </a:p>

</xml_diff>

<commit_message>
Deck direksi: timeline setelah go-live, naskah dan PDF diperbarui
Co-Authored-By: Claude Opus 5.5 <noreply@anthropic.com>
Claude-Session: https://claude.ai/code/session_01JEY5regGSA4jYBqyTUCMow
</commit_message>
<xml_diff>
--- a/docs/PID_POS_Paparan_Direksi_Template.pptx
+++ b/docs/PID_POS_Paparan_Direksi_Template.pptx
@@ -14,9 +14,10 @@
     <p:sldId id="262" r:id="rId8"/>
     <p:sldId id="263" r:id="rId9"/>
     <p:sldId id="264" r:id="rId10"/>
+    <p:sldId id="265" r:id="rId11"/>
   </p:sldIdLst>
   <p:notesMasterIdLst>
-    <p:notesMasterId r:id="rId11"/>
+    <p:notesMasterId r:id="rId12"/>
   </p:notesMasterIdLst>
   <p:sldSz cx="12192000" cy="6858000"/>
   <p:notesSz cx="6858000" cy="12192000"/>
@@ -115,12 +116,12 @@
   <p:extLst>
     <p:ext uri="{521415D9-36F7-43E2-AB2F-B90AF26B5E84}">
       <p14:sectionLst xmlns:p14="http://schemas.microsoft.com/office/powerpoint/2010/main">
-        <p14:section name="Pembuka" id="{0790b8da-cc3c-1c64-1c1c-068236e312a5}">
+        <p14:section name="Pembuka" id="{1f57e9f6-7307-d45c-6768-28fc0e9ec128}">
           <p14:sldIdLst>
             <p14:sldId id="256"/>
           </p14:sldIdLst>
         </p14:section>
-        <p14:section name="Aplikasi" id="{19147f7d-b5b3-ad0f-be31-39232a810ee6}">
+        <p14:section name="Aplikasi" id="{930fb973-41ea-6160-1560-5009e5e185ac}">
           <p14:sldIdLst>
             <p14:sldId id="257"/>
             <p14:sldId id="258"/>
@@ -129,11 +130,12 @@
             <p14:sldId id="261"/>
             <p14:sldId id="262"/>
             <p14:sldId id="263"/>
+            <p14:sldId id="264"/>
           </p14:sldIdLst>
         </p14:section>
-        <p14:section name="Penutup" id="{d7a2e5e7-81a8-9de3-0302-88b271e37b9f}">
+        <p14:section name="Penutup" id="{8cbf326f-9a9a-01a9-706e-e9e171c4d4b3}">
           <p14:sldIdLst>
-            <p14:sldId id="264"/>
+            <p14:sldId id="265"/>
           </p14:sldIdLst>
         </p14:section>
       </p14:sectionLst>
@@ -542,7 +544,7 @@
               <a:rPr lang="en-US" dirty="0"/>
               <a:t>Selamat pagi, Bapak dan Ibu Direksi.
 Pada kesempatan ini kami memaparkan PID POS, aplikasi toko kapal PT Pelita Indonesia Djaya yang terhubung langsung dengan SAP Business One.
-Kami akan menyampaikan apa itu PID POS, bagaimana alurnya, siapa saja yang terlibat, fitur utamanya, kasir di setiap dek, keunggulan, dan batasannya saat ini.</a:t>
+Kami akan menyampaikan apa itu PID POS, bagaimana alurnya, siapa saja yang terlibat, fitur utamanya, kasir di setiap dek, keunggulan, batasan saat ini, serta timeline setelah go-live.</a:t>
             </a:r>
             <a:endParaRPr lang="en-US" dirty="0"/>
           </a:p>
@@ -566,6 +568,95 @@
             <a:fld id="{F7021451-1387-4CA6-816F-3879F97B5CBC}" type="slidenum">
               <a:rPr lang="en-US"/>
               <a:t>1</a:t>
+            </a:fld>
+            <a:endParaRPr lang="en-US"/>
+          </a:p>
+        </p:txBody>
+      </p:sp>
+    </p:spTree>
+    <p:extLst>
+      <p:ext uri="{BB962C8B-B14F-4D97-AF65-F5344CB8AC3E}">
+        <p14:creationId xmlns:p14="http://schemas.microsoft.com/office/powerpoint/2010/main" val="1024086991"/>
+      </p:ext>
+    </p:extLst>
+  </p:cSld>
+  <p:clrMapOvr>
+    <a:masterClrMapping/>
+  </p:clrMapOvr>
+</p:notes>
+</file>
+
+<file path=ppt/notesSlides/notesSlide10.xml><?xml version="1.0" encoding="utf-8"?>
+<p:notes xmlns:a="http://schemas.openxmlformats.org/drawingml/2006/main" xmlns:r="http://schemas.openxmlformats.org/officeDocument/2006/relationships" xmlns:p="http://schemas.openxmlformats.org/presentationml/2006/main">
+  <p:cSld>
+    <p:spTree>
+      <p:nvGrpSpPr>
+        <p:cNvPr id="1" name=""/>
+        <p:cNvGrpSpPr/>
+        <p:nvPr/>
+      </p:nvGrpSpPr>
+      <p:grpSpPr>
+        <a:xfrm>
+          <a:off x="0" y="0"/>
+          <a:ext cx="0" cy="0"/>
+          <a:chOff x="0" y="0"/>
+          <a:chExt cx="0" cy="0"/>
+        </a:xfrm>
+      </p:grpSpPr>
+      <p:sp>
+        <p:nvSpPr>
+          <p:cNvPr id="2" name="Slide Image Placeholder 1"/>
+          <p:cNvSpPr>
+            <a:spLocks noGrp="1" noRot="1" noChangeAspect="1"/>
+          </p:cNvSpPr>
+          <p:nvPr>
+            <p:ph type="sldImg"/>
+          </p:nvPr>
+        </p:nvSpPr>
+        <p:spPr/>
+      </p:sp>
+      <p:sp>
+        <p:nvSpPr>
+          <p:cNvPr id="3" name="Notes Placeholder 2"/>
+          <p:cNvSpPr>
+            <a:spLocks noGrp="1"/>
+          </p:cNvSpPr>
+          <p:nvPr>
+            <p:ph type="body" idx="1"/>
+          </p:nvPr>
+        </p:nvSpPr>
+        <p:spPr/>
+        <p:txBody>
+          <a:bodyPr/>
+          <a:lstStyle/>
+          <a:p>
+            <a:r>
+              <a:rPr lang="en-US" dirty="0"/>
+              <a:t>Demikian paparan kami. PID POS: satu alur, dari kapal sampai kasir.
+Terima kasih. Kami persilakan Bapak dan Ibu Direksi untuk memberikan arahan atau pertanyaan.</a:t>
+            </a:r>
+            <a:endParaRPr lang="en-US" dirty="0"/>
+          </a:p>
+        </p:txBody>
+      </p:sp>
+      <p:sp>
+        <p:nvSpPr>
+          <p:cNvPr id="4" name="Slide Number Placeholder 3"/>
+          <p:cNvSpPr>
+            <a:spLocks noGrp="1"/>
+          </p:cNvSpPr>
+          <p:nvPr>
+            <p:ph type="sldNum" sz="quarter" idx="10"/>
+          </p:nvPr>
+        </p:nvSpPr>
+        <p:spPr/>
+        <p:txBody>
+          <a:bodyPr/>
+          <a:lstStyle/>
+          <a:p>
+            <a:fld id="{F7021451-1387-4CA6-816F-3879F97B5CBC}" type="slidenum">
+              <a:rPr lang="en-US"/>
+              <a:t>10</a:t>
             </a:fld>
             <a:endParaRPr lang="en-US"/>
           </a:p>
@@ -1271,8 +1362,13 @@
           <a:p>
             <a:r>
               <a:rPr lang="en-US" dirty="0"/>
-              <a:t>Demikian paparan kami. PID POS: satu alur, dari kapal sampai kasir.
-Terima kasih. Kami persilakan Bapak dan Ibu Direksi untuk memberikan arahan atau pertanyaan.</a:t>
+              <a:t>Berikut usulan timeline setelah go-live.
+PID POS mulai digunakan pada 27 Oktober 2026.
+Dua minggu pertama, sampai 9 November, adalah masa pendampingan intensif. Tim pendamping siaga setiap hari, dan setiap kendala pengguna ditangani dengan cepat.
+Sampai akhir November, aplikasi masuk tahap stabilisasi: transaksi dan sinkronisasi ke SAP dipantau, penyesuaian kecil dilakukan, dan pelatihan ulang diberikan bila perlu.
+Pada Desember 2026, kami menyampaikan laporan evaluasi kepada Direksi, mencakup tingkat penggunaan, akurasi stok, dan kecepatan persetujuan.
+Selanjutnya pada 2027, pengembangan berlanjut dengan aktivasi fitur retur dan kas keluar, serta kajian aplikasi kasir untuk iOS.
+Jadwal ini masih usulan dan dapat disesuaikan dengan arahan Direksi.</a:t>
             </a:r>
             <a:endParaRPr lang="en-US" dirty="0"/>
           </a:p>
@@ -2027,6 +2123,141 @@
 </p:sld>
 </file>
 
+<file path=ppt/slides/slide10.xml><?xml version="1.0" encoding="utf-8"?>
+<p:sld xmlns:a="http://schemas.openxmlformats.org/drawingml/2006/main" xmlns:r="http://schemas.openxmlformats.org/officeDocument/2006/relationships" xmlns:p="http://schemas.openxmlformats.org/presentationml/2006/main">
+  <p:cSld name="Slide 10">
+    <p:spTree>
+      <p:nvGrpSpPr>
+        <p:cNvPr id="1" name=""/>
+        <p:cNvGrpSpPr/>
+        <p:nvPr/>
+      </p:nvGrpSpPr>
+      <p:grpSpPr>
+        <a:xfrm>
+          <a:off x="0" y="0"/>
+          <a:ext cx="0" cy="0"/>
+          <a:chOff x="0" y="0"/>
+          <a:chExt cx="0" cy="0"/>
+        </a:xfrm>
+      </p:grpSpPr>
+      <p:sp>
+        <p:nvSpPr>
+          <p:cNvPr id="2" name="Text 0"/>
+          <p:cNvSpPr/>
+          <p:nvPr>
+            <p:ph idx="100" type="title" hasCustomPrompt="1"/>
+          </p:nvPr>
+        </p:nvSpPr>
+        <p:spPr>
+          <a:xfrm>
+            <a:off x="612648" y="2148840"/>
+            <a:ext cx="6949440" cy="868680"/>
+          </a:xfrm>
+          <a:prstGeom prst="rect">
+            <a:avLst/>
+          </a:prstGeom>
+          <a:noFill/>
+          <a:ln/>
+        </p:spPr>
+        <p:txBody>
+          <a:bodyPr wrap="square" lIns="0" tIns="0" rIns="0" bIns="0" rtlCol="0" anchor="b"/>
+          <a:lstStyle/>
+          <a:p>
+            <a:pPr algn="l" indent="0" marL="0">
+              <a:buNone/>
+            </a:pPr>
+            <a:r>
+              <a:rPr lang="en-US" sz="4400" b="1" dirty="0">
+                <a:solidFill>
+                  <a:schemeClr val="bg1"/>
+                </a:solidFill>
+              </a:rPr>
+              <a:t>Terima Kasih</a:t>
+            </a:r>
+            <a:endParaRPr lang="en-US" sz="4400" dirty="0"/>
+          </a:p>
+        </p:txBody>
+      </p:sp>
+      <p:sp>
+        <p:nvSpPr>
+          <p:cNvPr id="3" name="Text 1"/>
+          <p:cNvSpPr txBox="1"/>
+          <p:nvPr/>
+        </p:nvSpPr>
+        <p:spPr>
+          <a:xfrm>
+            <a:off x="612648" y="3246120"/>
+            <a:ext cx="6766560" cy="457200"/>
+          </a:xfrm>
+          <a:prstGeom prst="rect">
+            <a:avLst/>
+          </a:prstGeom>
+          <a:noFill/>
+          <a:ln/>
+        </p:spPr>
+        <p:txBody>
+          <a:bodyPr wrap="square" lIns="0" tIns="0" rIns="0" bIns="0" rtlCol="0" anchor="t"/>
+          <a:lstStyle/>
+          <a:p>
+            <a:pPr indent="0" marL="0">
+              <a:buNone/>
+            </a:pPr>
+            <a:r>
+              <a:rPr lang="en-US" sz="2000" b="1" dirty="0">
+                <a:solidFill>
+                  <a:srgbClr val="FFFFFF"/>
+                </a:solidFill>
+              </a:rPr>
+              <a:t>PID POS · Satu alur, dari kapal sampai kasir.</a:t>
+            </a:r>
+            <a:endParaRPr lang="en-US" sz="2000" dirty="0"/>
+          </a:p>
+        </p:txBody>
+      </p:sp>
+      <p:sp>
+        <p:nvSpPr>
+          <p:cNvPr id="4" name="Text 2"/>
+          <p:cNvSpPr txBox="1"/>
+          <p:nvPr/>
+        </p:nvSpPr>
+        <p:spPr>
+          <a:xfrm>
+            <a:off x="612648" y="3749040"/>
+            <a:ext cx="6766560" cy="365760"/>
+          </a:xfrm>
+          <a:prstGeom prst="rect">
+            <a:avLst/>
+          </a:prstGeom>
+          <a:noFill/>
+          <a:ln/>
+        </p:spPr>
+        <p:txBody>
+          <a:bodyPr wrap="square" lIns="0" tIns="0" rIns="0" bIns="0" rtlCol="0" anchor="t"/>
+          <a:lstStyle/>
+          <a:p>
+            <a:pPr indent="0" marL="0">
+              <a:buNone/>
+            </a:pPr>
+            <a:r>
+              <a:rPr lang="en-US" sz="1600" dirty="0">
+                <a:solidFill>
+                  <a:srgbClr val="D6E4F5"/>
+                </a:solidFill>
+              </a:rPr>
+              <a:t>PT Pelita Indonesia Djaya (PELNI Services)</a:t>
+            </a:r>
+            <a:endParaRPr lang="en-US" sz="1600" dirty="0"/>
+          </a:p>
+        </p:txBody>
+      </p:sp>
+    </p:spTree>
+  </p:cSld>
+  <p:clrMapOvr>
+    <a:masterClrMapping/>
+  </p:clrMapOvr>
+</p:sld>
+</file>
+
 <file path=ppt/slides/slide2.xml><?xml version="1.0" encoding="utf-8"?>
 <p:sld xmlns:a="http://schemas.openxmlformats.org/drawingml/2006/main" xmlns:r="http://schemas.openxmlformats.org/officeDocument/2006/relationships" xmlns:p="http://schemas.openxmlformats.org/presentationml/2006/main">
   <p:cSld name="Slide 2">
@@ -8401,8 +8632,8 @@
         </p:nvSpPr>
         <p:spPr>
           <a:xfrm>
-            <a:off x="612648" y="2148840"/>
-            <a:ext cx="6949440" cy="868680"/>
+            <a:off x="685800" y="914400"/>
+            <a:ext cx="10835640" cy="640080"/>
           </a:xfrm>
           <a:prstGeom prst="rect">
             <a:avLst/>
@@ -8411,59 +8642,46 @@
           <a:ln/>
         </p:spPr>
         <p:txBody>
-          <a:bodyPr wrap="square" lIns="0" tIns="0" rIns="0" bIns="0" rtlCol="0" anchor="b"/>
+          <a:bodyPr wrap="square" lIns="0" tIns="0" rIns="0" bIns="0" rtlCol="0" anchor="ctr"/>
           <a:lstStyle/>
           <a:p>
             <a:pPr algn="l" indent="0" marL="0">
               <a:buNone/>
             </a:pPr>
             <a:r>
-              <a:rPr lang="en-US" sz="4400" b="1" dirty="0">
-                <a:solidFill>
-                  <a:schemeClr val="bg1"/>
-                </a:solidFill>
-              </a:rPr>
-              <a:t>Terima Kasih</a:t>
-            </a:r>
-            <a:endParaRPr lang="en-US" sz="4400" dirty="0"/>
-          </a:p>
-        </p:txBody>
-      </p:sp>
-      <p:sp>
-        <p:nvSpPr>
-          <p:cNvPr id="3" name="Text 1"/>
-          <p:cNvSpPr txBox="1"/>
-          <p:nvPr/>
-        </p:nvSpPr>
-        <p:spPr>
-          <a:xfrm>
-            <a:off x="612648" y="3246120"/>
-            <a:ext cx="6766560" cy="457200"/>
-          </a:xfrm>
-          <a:prstGeom prst="rect">
-            <a:avLst/>
-          </a:prstGeom>
-          <a:noFill/>
-          <a:ln/>
-        </p:spPr>
-        <p:txBody>
-          <a:bodyPr wrap="square" lIns="0" tIns="0" rIns="0" bIns="0" rtlCol="0" anchor="t"/>
-          <a:lstStyle/>
-          <a:p>
-            <a:pPr indent="0" marL="0">
-              <a:buNone/>
-            </a:pPr>
-            <a:r>
-              <a:rPr lang="en-US" sz="2000" b="1" dirty="0">
-                <a:solidFill>
-                  <a:srgbClr val="FFFFFF"/>
-                </a:solidFill>
-              </a:rPr>
-              <a:t>PID POS · Satu alur, dari kapal sampai kasir.</a:t>
-            </a:r>
-            <a:endParaRPr lang="en-US" sz="2000" dirty="0"/>
-          </a:p>
-        </p:txBody>
+              <a:rPr lang="en-US" sz="3000" b="1" dirty="0">
+                <a:solidFill>
+                  <a:schemeClr val="tx2"/>
+                </a:solidFill>
+              </a:rPr>
+              <a:t>Timeline setelah go-live</a:t>
+            </a:r>
+            <a:endParaRPr lang="en-US" sz="3000" dirty="0"/>
+          </a:p>
+        </p:txBody>
+      </p:sp>
+      <p:sp>
+        <p:nvSpPr>
+          <p:cNvPr id="3" name="Garis timeline"/>
+          <p:cNvSpPr/>
+          <p:nvPr/>
+        </p:nvSpPr>
+        <p:spPr>
+          <a:xfrm>
+            <a:off x="1714500" y="2331720"/>
+            <a:ext cx="8778240" cy="0"/>
+          </a:xfrm>
+          <a:prstGeom prst="line">
+            <a:avLst/>
+          </a:prstGeom>
+          <a:noFill/>
+          <a:ln w="38100">
+            <a:solidFill>
+              <a:srgbClr val="5AB4E5"/>
+            </a:solidFill>
+            <a:prstDash val="solid"/>
+          </a:ln>
+        </p:spPr>
       </p:sp>
       <p:sp>
         <p:nvSpPr>
@@ -8473,8 +8691,8 @@
         </p:nvSpPr>
         <p:spPr>
           <a:xfrm>
-            <a:off x="612648" y="3749040"/>
-            <a:ext cx="6766560" cy="365760"/>
+            <a:off x="685800" y="1691640"/>
+            <a:ext cx="2057400" cy="320040"/>
           </a:xfrm>
           <a:prstGeom prst="rect">
             <a:avLst/>
@@ -8486,18 +8704,1023 @@
           <a:bodyPr wrap="square" lIns="0" tIns="0" rIns="0" bIns="0" rtlCol="0" anchor="t"/>
           <a:lstStyle/>
           <a:p>
+            <a:pPr algn="ctr" indent="0" marL="0">
+              <a:buNone/>
+            </a:pPr>
+            <a:r>
+              <a:rPr lang="en-US" sz="1300" b="1" dirty="0">
+                <a:solidFill>
+                  <a:srgbClr val="F2762E"/>
+                </a:solidFill>
+              </a:rPr>
+              <a:t>27 Okt 2026</a:t>
+            </a:r>
+            <a:endParaRPr lang="en-US" sz="1300" dirty="0"/>
+          </a:p>
+        </p:txBody>
+      </p:sp>
+      <p:sp>
+        <p:nvSpPr>
+          <p:cNvPr id="5" name="Titik Go-live"/>
+          <p:cNvSpPr/>
+          <p:nvPr/>
+        </p:nvSpPr>
+        <p:spPr>
+          <a:xfrm>
+            <a:off x="1549908" y="2167128"/>
+            <a:ext cx="329184" cy="329184"/>
+          </a:xfrm>
+          <a:prstGeom prst="ellipse">
+            <a:avLst/>
+          </a:prstGeom>
+          <a:solidFill>
+            <a:srgbClr val="F2762E"/>
+          </a:solidFill>
+          <a:ln w="31750">
+            <a:solidFill>
+              <a:srgbClr val="FFFFFF"/>
+            </a:solidFill>
+            <a:prstDash val="solid"/>
+          </a:ln>
+        </p:spPr>
+      </p:sp>
+      <p:sp>
+        <p:nvSpPr>
+          <p:cNvPr id="6" name="Fase Go-live"/>
+          <p:cNvSpPr/>
+          <p:nvPr/>
+        </p:nvSpPr>
+        <p:spPr>
+          <a:xfrm>
+            <a:off x="685800" y="2697480"/>
+            <a:ext cx="2057400" cy="2331720"/>
+          </a:xfrm>
+          <a:prstGeom prst="roundRect">
+            <a:avLst>
+              <a:gd name="adj" fmla="val 5333"/>
+            </a:avLst>
+          </a:prstGeom>
+          <a:solidFill>
+            <a:srgbClr val="FFFFFF"/>
+          </a:solidFill>
+          <a:ln w="9525">
+            <a:solidFill>
+              <a:srgbClr val="E3E9F3"/>
+            </a:solidFill>
+            <a:prstDash val="solid"/>
+          </a:ln>
+          <a:effectLst>
+            <a:outerShdw sx="100000" sy="100000" kx="0" ky="0" algn="bl" rotWithShape="0" blurRad="101600" dist="25400" dir="5400000">
+              <a:srgbClr val="274289">
+                <a:alpha val="12000"/>
+              </a:srgbClr>
+            </a:outerShdw>
+          </a:effectLst>
+        </p:spPr>
+      </p:sp>
+      <p:sp>
+        <p:nvSpPr>
+          <p:cNvPr id="7" name="Aksen"/>
+          <p:cNvSpPr/>
+          <p:nvPr/>
+        </p:nvSpPr>
+        <p:spPr>
+          <a:xfrm>
+            <a:off x="868680" y="2880360"/>
+            <a:ext cx="411480" cy="54864"/>
+          </a:xfrm>
+          <a:prstGeom prst="rect">
+            <a:avLst/>
+          </a:prstGeom>
+          <a:solidFill>
+            <a:srgbClr val="F2762E"/>
+          </a:solidFill>
+          <a:ln w="12700">
+            <a:solidFill>
+              <a:srgbClr val="F2762E"/>
+            </a:solidFill>
+            <a:prstDash val="solid"/>
+          </a:ln>
+        </p:spPr>
+      </p:sp>
+      <p:sp>
+        <p:nvSpPr>
+          <p:cNvPr id="8" name="Text 6"/>
+          <p:cNvSpPr txBox="1"/>
+          <p:nvPr/>
+        </p:nvSpPr>
+        <p:spPr>
+          <a:xfrm>
+            <a:off x="868680" y="3017520"/>
+            <a:ext cx="1691640" cy="685800"/>
+          </a:xfrm>
+          <a:prstGeom prst="rect">
+            <a:avLst/>
+          </a:prstGeom>
+          <a:noFill/>
+          <a:ln/>
+        </p:spPr>
+        <p:txBody>
+          <a:bodyPr wrap="square" lIns="0" tIns="0" rIns="0" bIns="0" rtlCol="0" anchor="t"/>
+          <a:lstStyle/>
+          <a:p>
             <a:pPr indent="0" marL="0">
               <a:buNone/>
             </a:pPr>
             <a:r>
-              <a:rPr lang="en-US" sz="1600" dirty="0">
-                <a:solidFill>
-                  <a:srgbClr val="D6E4F5"/>
-                </a:solidFill>
-              </a:rPr>
-              <a:t>PT Pelita Indonesia Djaya (PELNI Services)</a:t>
-            </a:r>
-            <a:endParaRPr lang="en-US" sz="1600" dirty="0"/>
+              <a:rPr lang="en-US" sz="1700" b="1" dirty="0">
+                <a:solidFill>
+                  <a:srgbClr val="274289"/>
+                </a:solidFill>
+              </a:rPr>
+              <a:t>Go-live</a:t>
+            </a:r>
+            <a:endParaRPr lang="en-US" sz="1700" dirty="0"/>
+          </a:p>
+        </p:txBody>
+      </p:sp>
+      <p:sp>
+        <p:nvSpPr>
+          <p:cNvPr id="9" name="Text 7"/>
+          <p:cNvSpPr txBox="1"/>
+          <p:nvPr/>
+        </p:nvSpPr>
+        <p:spPr>
+          <a:xfrm>
+            <a:off x="868680" y="3703320"/>
+            <a:ext cx="1691640" cy="1234440"/>
+          </a:xfrm>
+          <a:prstGeom prst="rect">
+            <a:avLst/>
+          </a:prstGeom>
+          <a:noFill/>
+          <a:ln/>
+        </p:spPr>
+        <p:txBody>
+          <a:bodyPr wrap="square" lIns="0" tIns="0" rIns="0" bIns="0" rtlCol="0" anchor="t"/>
+          <a:lstStyle/>
+          <a:p>
+            <a:pPr indent="0" marL="0">
+              <a:buNone/>
+            </a:pPr>
+            <a:r>
+              <a:rPr lang="en-US" sz="1250" dirty="0">
+                <a:solidFill>
+                  <a:srgbClr val="1B2437"/>
+                </a:solidFill>
+              </a:rPr>
+              <a:t>PID POS resmi digunakan di kapal, DC, dan kantor pusat.</a:t>
+            </a:r>
+            <a:endParaRPr lang="en-US" sz="1250" dirty="0"/>
+          </a:p>
+        </p:txBody>
+      </p:sp>
+      <p:sp>
+        <p:nvSpPr>
+          <p:cNvPr id="10" name="Text 8"/>
+          <p:cNvSpPr txBox="1"/>
+          <p:nvPr/>
+        </p:nvSpPr>
+        <p:spPr>
+          <a:xfrm>
+            <a:off x="2880360" y="1691640"/>
+            <a:ext cx="2057400" cy="320040"/>
+          </a:xfrm>
+          <a:prstGeom prst="rect">
+            <a:avLst/>
+          </a:prstGeom>
+          <a:noFill/>
+          <a:ln/>
+        </p:spPr>
+        <p:txBody>
+          <a:bodyPr wrap="square" lIns="0" tIns="0" rIns="0" bIns="0" rtlCol="0" anchor="t"/>
+          <a:lstStyle/>
+          <a:p>
+            <a:pPr algn="ctr" indent="0" marL="0">
+              <a:buNone/>
+            </a:pPr>
+            <a:r>
+              <a:rPr lang="en-US" sz="1300" b="1" dirty="0">
+                <a:solidFill>
+                  <a:srgbClr val="5B6B86"/>
+                </a:solidFill>
+              </a:rPr>
+              <a:t>27 Okt – 9 Nov</a:t>
+            </a:r>
+            <a:endParaRPr lang="en-US" sz="1300" dirty="0"/>
+          </a:p>
+        </p:txBody>
+      </p:sp>
+      <p:sp>
+        <p:nvSpPr>
+          <p:cNvPr id="11" name="Titik Pendampingan intensif"/>
+          <p:cNvSpPr/>
+          <p:nvPr/>
+        </p:nvSpPr>
+        <p:spPr>
+          <a:xfrm>
+            <a:off x="3744468" y="2167128"/>
+            <a:ext cx="329184" cy="329184"/>
+          </a:xfrm>
+          <a:prstGeom prst="ellipse">
+            <a:avLst/>
+          </a:prstGeom>
+          <a:solidFill>
+            <a:srgbClr val="274289"/>
+          </a:solidFill>
+          <a:ln w="31750">
+            <a:solidFill>
+              <a:srgbClr val="FFFFFF"/>
+            </a:solidFill>
+            <a:prstDash val="solid"/>
+          </a:ln>
+        </p:spPr>
+      </p:sp>
+      <p:sp>
+        <p:nvSpPr>
+          <p:cNvPr id="12" name="Fase Pendampingan intensif"/>
+          <p:cNvSpPr/>
+          <p:nvPr/>
+        </p:nvSpPr>
+        <p:spPr>
+          <a:xfrm>
+            <a:off x="2880360" y="2697480"/>
+            <a:ext cx="2057400" cy="2331720"/>
+          </a:xfrm>
+          <a:prstGeom prst="roundRect">
+            <a:avLst>
+              <a:gd name="adj" fmla="val 5333"/>
+            </a:avLst>
+          </a:prstGeom>
+          <a:solidFill>
+            <a:srgbClr val="EEF3FA"/>
+          </a:solidFill>
+          <a:ln w="9525">
+            <a:solidFill>
+              <a:srgbClr val="EEF3FA"/>
+            </a:solidFill>
+            <a:prstDash val="solid"/>
+          </a:ln>
+          <a:effectLst>
+            <a:outerShdw sx="100000" sy="100000" kx="0" ky="0" algn="bl" rotWithShape="0" blurRad="101600" dist="25400" dir="5400000">
+              <a:srgbClr val="274289">
+                <a:alpha val="12000"/>
+              </a:srgbClr>
+            </a:outerShdw>
+          </a:effectLst>
+        </p:spPr>
+      </p:sp>
+      <p:sp>
+        <p:nvSpPr>
+          <p:cNvPr id="13" name="Aksen"/>
+          <p:cNvSpPr/>
+          <p:nvPr/>
+        </p:nvSpPr>
+        <p:spPr>
+          <a:xfrm>
+            <a:off x="3063240" y="2880360"/>
+            <a:ext cx="411480" cy="54864"/>
+          </a:xfrm>
+          <a:prstGeom prst="rect">
+            <a:avLst/>
+          </a:prstGeom>
+          <a:solidFill>
+            <a:srgbClr val="5AB4E5"/>
+          </a:solidFill>
+          <a:ln w="12700">
+            <a:solidFill>
+              <a:srgbClr val="5AB4E5"/>
+            </a:solidFill>
+            <a:prstDash val="solid"/>
+          </a:ln>
+        </p:spPr>
+      </p:sp>
+      <p:sp>
+        <p:nvSpPr>
+          <p:cNvPr id="14" name="Text 12"/>
+          <p:cNvSpPr txBox="1"/>
+          <p:nvPr/>
+        </p:nvSpPr>
+        <p:spPr>
+          <a:xfrm>
+            <a:off x="3063240" y="3017520"/>
+            <a:ext cx="1691640" cy="685800"/>
+          </a:xfrm>
+          <a:prstGeom prst="rect">
+            <a:avLst/>
+          </a:prstGeom>
+          <a:noFill/>
+          <a:ln/>
+        </p:spPr>
+        <p:txBody>
+          <a:bodyPr wrap="square" lIns="0" tIns="0" rIns="0" bIns="0" rtlCol="0" anchor="t"/>
+          <a:lstStyle/>
+          <a:p>
+            <a:pPr indent="0" marL="0">
+              <a:buNone/>
+            </a:pPr>
+            <a:r>
+              <a:rPr lang="en-US" sz="1700" b="1" dirty="0">
+                <a:solidFill>
+                  <a:srgbClr val="274289"/>
+                </a:solidFill>
+              </a:rPr>
+              <a:t>Pendampingan intensif</a:t>
+            </a:r>
+            <a:endParaRPr lang="en-US" sz="1700" dirty="0"/>
+          </a:p>
+        </p:txBody>
+      </p:sp>
+      <p:sp>
+        <p:nvSpPr>
+          <p:cNvPr id="15" name="Text 13"/>
+          <p:cNvSpPr txBox="1"/>
+          <p:nvPr/>
+        </p:nvSpPr>
+        <p:spPr>
+          <a:xfrm>
+            <a:off x="3063240" y="3703320"/>
+            <a:ext cx="1691640" cy="1234440"/>
+          </a:xfrm>
+          <a:prstGeom prst="rect">
+            <a:avLst/>
+          </a:prstGeom>
+          <a:noFill/>
+          <a:ln/>
+        </p:spPr>
+        <p:txBody>
+          <a:bodyPr wrap="square" lIns="0" tIns="0" rIns="0" bIns="0" rtlCol="0" anchor="t"/>
+          <a:lstStyle/>
+          <a:p>
+            <a:pPr indent="0" marL="0">
+              <a:buNone/>
+            </a:pPr>
+            <a:r>
+              <a:rPr lang="en-US" sz="1250" dirty="0">
+                <a:solidFill>
+                  <a:srgbClr val="1B2437"/>
+                </a:solidFill>
+              </a:rPr>
+              <a:t>Tim pendamping siaga setiap hari; kendala pengguna ditangani cepat.</a:t>
+            </a:r>
+            <a:endParaRPr lang="en-US" sz="1250" dirty="0"/>
+          </a:p>
+        </p:txBody>
+      </p:sp>
+      <p:sp>
+        <p:nvSpPr>
+          <p:cNvPr id="16" name="Text 14"/>
+          <p:cNvSpPr txBox="1"/>
+          <p:nvPr/>
+        </p:nvSpPr>
+        <p:spPr>
+          <a:xfrm>
+            <a:off x="5074920" y="1691640"/>
+            <a:ext cx="2057400" cy="320040"/>
+          </a:xfrm>
+          <a:prstGeom prst="rect">
+            <a:avLst/>
+          </a:prstGeom>
+          <a:noFill/>
+          <a:ln/>
+        </p:spPr>
+        <p:txBody>
+          <a:bodyPr wrap="square" lIns="0" tIns="0" rIns="0" bIns="0" rtlCol="0" anchor="t"/>
+          <a:lstStyle/>
+          <a:p>
+            <a:pPr algn="ctr" indent="0" marL="0">
+              <a:buNone/>
+            </a:pPr>
+            <a:r>
+              <a:rPr lang="en-US" sz="1300" b="1" dirty="0">
+                <a:solidFill>
+                  <a:srgbClr val="5B6B86"/>
+                </a:solidFill>
+              </a:rPr>
+              <a:t>10 – 30 Nov</a:t>
+            </a:r>
+            <a:endParaRPr lang="en-US" sz="1300" dirty="0"/>
+          </a:p>
+        </p:txBody>
+      </p:sp>
+      <p:sp>
+        <p:nvSpPr>
+          <p:cNvPr id="17" name="Titik Stabilisasi"/>
+          <p:cNvSpPr/>
+          <p:nvPr/>
+        </p:nvSpPr>
+        <p:spPr>
+          <a:xfrm>
+            <a:off x="5939028" y="2167128"/>
+            <a:ext cx="329184" cy="329184"/>
+          </a:xfrm>
+          <a:prstGeom prst="ellipse">
+            <a:avLst/>
+          </a:prstGeom>
+          <a:solidFill>
+            <a:srgbClr val="274289"/>
+          </a:solidFill>
+          <a:ln w="31750">
+            <a:solidFill>
+              <a:srgbClr val="FFFFFF"/>
+            </a:solidFill>
+            <a:prstDash val="solid"/>
+          </a:ln>
+        </p:spPr>
+      </p:sp>
+      <p:sp>
+        <p:nvSpPr>
+          <p:cNvPr id="18" name="Fase Stabilisasi"/>
+          <p:cNvSpPr/>
+          <p:nvPr/>
+        </p:nvSpPr>
+        <p:spPr>
+          <a:xfrm>
+            <a:off x="5074920" y="2697480"/>
+            <a:ext cx="2057400" cy="2331720"/>
+          </a:xfrm>
+          <a:prstGeom prst="roundRect">
+            <a:avLst>
+              <a:gd name="adj" fmla="val 5333"/>
+            </a:avLst>
+          </a:prstGeom>
+          <a:solidFill>
+            <a:srgbClr val="EEF3FA"/>
+          </a:solidFill>
+          <a:ln w="9525">
+            <a:solidFill>
+              <a:srgbClr val="EEF3FA"/>
+            </a:solidFill>
+            <a:prstDash val="solid"/>
+          </a:ln>
+          <a:effectLst>
+            <a:outerShdw sx="100000" sy="100000" kx="0" ky="0" algn="bl" rotWithShape="0" blurRad="101600" dist="25400" dir="5400000">
+              <a:srgbClr val="274289">
+                <a:alpha val="12000"/>
+              </a:srgbClr>
+            </a:outerShdw>
+          </a:effectLst>
+        </p:spPr>
+      </p:sp>
+      <p:sp>
+        <p:nvSpPr>
+          <p:cNvPr id="19" name="Aksen"/>
+          <p:cNvSpPr/>
+          <p:nvPr/>
+        </p:nvSpPr>
+        <p:spPr>
+          <a:xfrm>
+            <a:off x="5257800" y="2880360"/>
+            <a:ext cx="411480" cy="54864"/>
+          </a:xfrm>
+          <a:prstGeom prst="rect">
+            <a:avLst/>
+          </a:prstGeom>
+          <a:solidFill>
+            <a:srgbClr val="5AB4E5"/>
+          </a:solidFill>
+          <a:ln w="12700">
+            <a:solidFill>
+              <a:srgbClr val="5AB4E5"/>
+            </a:solidFill>
+            <a:prstDash val="solid"/>
+          </a:ln>
+        </p:spPr>
+      </p:sp>
+      <p:sp>
+        <p:nvSpPr>
+          <p:cNvPr id="20" name="Text 18"/>
+          <p:cNvSpPr txBox="1"/>
+          <p:nvPr/>
+        </p:nvSpPr>
+        <p:spPr>
+          <a:xfrm>
+            <a:off x="5257800" y="3017520"/>
+            <a:ext cx="1691640" cy="685800"/>
+          </a:xfrm>
+          <a:prstGeom prst="rect">
+            <a:avLst/>
+          </a:prstGeom>
+          <a:noFill/>
+          <a:ln/>
+        </p:spPr>
+        <p:txBody>
+          <a:bodyPr wrap="square" lIns="0" tIns="0" rIns="0" bIns="0" rtlCol="0" anchor="t"/>
+          <a:lstStyle/>
+          <a:p>
+            <a:pPr indent="0" marL="0">
+              <a:buNone/>
+            </a:pPr>
+            <a:r>
+              <a:rPr lang="en-US" sz="1700" b="1" dirty="0">
+                <a:solidFill>
+                  <a:srgbClr val="274289"/>
+                </a:solidFill>
+              </a:rPr>
+              <a:t>Stabilisasi</a:t>
+            </a:r>
+            <a:endParaRPr lang="en-US" sz="1700" dirty="0"/>
+          </a:p>
+        </p:txBody>
+      </p:sp>
+      <p:sp>
+        <p:nvSpPr>
+          <p:cNvPr id="21" name="Text 19"/>
+          <p:cNvSpPr txBox="1"/>
+          <p:nvPr/>
+        </p:nvSpPr>
+        <p:spPr>
+          <a:xfrm>
+            <a:off x="5257800" y="3703320"/>
+            <a:ext cx="1691640" cy="1234440"/>
+          </a:xfrm>
+          <a:prstGeom prst="rect">
+            <a:avLst/>
+          </a:prstGeom>
+          <a:noFill/>
+          <a:ln/>
+        </p:spPr>
+        <p:txBody>
+          <a:bodyPr wrap="square" lIns="0" tIns="0" rIns="0" bIns="0" rtlCol="0" anchor="t"/>
+          <a:lstStyle/>
+          <a:p>
+            <a:pPr indent="0" marL="0">
+              <a:buNone/>
+            </a:pPr>
+            <a:r>
+              <a:rPr lang="en-US" sz="1250" dirty="0">
+                <a:solidFill>
+                  <a:srgbClr val="1B2437"/>
+                </a:solidFill>
+              </a:rPr>
+              <a:t>Pemantauan transaksi dan sinkron SAP, penyesuaian kecil, pelatihan ulang bila perlu.</a:t>
+            </a:r>
+            <a:endParaRPr lang="en-US" sz="1250" dirty="0"/>
+          </a:p>
+        </p:txBody>
+      </p:sp>
+      <p:sp>
+        <p:nvSpPr>
+          <p:cNvPr id="22" name="Text 20"/>
+          <p:cNvSpPr txBox="1"/>
+          <p:nvPr/>
+        </p:nvSpPr>
+        <p:spPr>
+          <a:xfrm>
+            <a:off x="7269480" y="1691640"/>
+            <a:ext cx="2057400" cy="320040"/>
+          </a:xfrm>
+          <a:prstGeom prst="rect">
+            <a:avLst/>
+          </a:prstGeom>
+          <a:noFill/>
+          <a:ln/>
+        </p:spPr>
+        <p:txBody>
+          <a:bodyPr wrap="square" lIns="0" tIns="0" rIns="0" bIns="0" rtlCol="0" anchor="t"/>
+          <a:lstStyle/>
+          <a:p>
+            <a:pPr algn="ctr" indent="0" marL="0">
+              <a:buNone/>
+            </a:pPr>
+            <a:r>
+              <a:rPr lang="en-US" sz="1300" b="1" dirty="0">
+                <a:solidFill>
+                  <a:srgbClr val="5B6B86"/>
+                </a:solidFill>
+              </a:rPr>
+              <a:t>Desember 2026</a:t>
+            </a:r>
+            <a:endParaRPr lang="en-US" sz="1300" dirty="0"/>
+          </a:p>
+        </p:txBody>
+      </p:sp>
+      <p:sp>
+        <p:nvSpPr>
+          <p:cNvPr id="23" name="Titik Evaluasi"/>
+          <p:cNvSpPr/>
+          <p:nvPr/>
+        </p:nvSpPr>
+        <p:spPr>
+          <a:xfrm>
+            <a:off x="8133588" y="2167128"/>
+            <a:ext cx="329184" cy="329184"/>
+          </a:xfrm>
+          <a:prstGeom prst="ellipse">
+            <a:avLst/>
+          </a:prstGeom>
+          <a:solidFill>
+            <a:srgbClr val="274289"/>
+          </a:solidFill>
+          <a:ln w="31750">
+            <a:solidFill>
+              <a:srgbClr val="FFFFFF"/>
+            </a:solidFill>
+            <a:prstDash val="solid"/>
+          </a:ln>
+        </p:spPr>
+      </p:sp>
+      <p:sp>
+        <p:nvSpPr>
+          <p:cNvPr id="24" name="Fase Evaluasi"/>
+          <p:cNvSpPr/>
+          <p:nvPr/>
+        </p:nvSpPr>
+        <p:spPr>
+          <a:xfrm>
+            <a:off x="7269480" y="2697480"/>
+            <a:ext cx="2057400" cy="2331720"/>
+          </a:xfrm>
+          <a:prstGeom prst="roundRect">
+            <a:avLst>
+              <a:gd name="adj" fmla="val 5333"/>
+            </a:avLst>
+          </a:prstGeom>
+          <a:solidFill>
+            <a:srgbClr val="EEF3FA"/>
+          </a:solidFill>
+          <a:ln w="9525">
+            <a:solidFill>
+              <a:srgbClr val="EEF3FA"/>
+            </a:solidFill>
+            <a:prstDash val="solid"/>
+          </a:ln>
+          <a:effectLst>
+            <a:outerShdw sx="100000" sy="100000" kx="0" ky="0" algn="bl" rotWithShape="0" blurRad="101600" dist="25400" dir="5400000">
+              <a:srgbClr val="274289">
+                <a:alpha val="12000"/>
+              </a:srgbClr>
+            </a:outerShdw>
+          </a:effectLst>
+        </p:spPr>
+      </p:sp>
+      <p:sp>
+        <p:nvSpPr>
+          <p:cNvPr id="25" name="Aksen"/>
+          <p:cNvSpPr/>
+          <p:nvPr/>
+        </p:nvSpPr>
+        <p:spPr>
+          <a:xfrm>
+            <a:off x="7452360" y="2880360"/>
+            <a:ext cx="411480" cy="54864"/>
+          </a:xfrm>
+          <a:prstGeom prst="rect">
+            <a:avLst/>
+          </a:prstGeom>
+          <a:solidFill>
+            <a:srgbClr val="5AB4E5"/>
+          </a:solidFill>
+          <a:ln w="12700">
+            <a:solidFill>
+              <a:srgbClr val="5AB4E5"/>
+            </a:solidFill>
+            <a:prstDash val="solid"/>
+          </a:ln>
+        </p:spPr>
+      </p:sp>
+      <p:sp>
+        <p:nvSpPr>
+          <p:cNvPr id="26" name="Text 24"/>
+          <p:cNvSpPr txBox="1"/>
+          <p:nvPr/>
+        </p:nvSpPr>
+        <p:spPr>
+          <a:xfrm>
+            <a:off x="7452360" y="3017520"/>
+            <a:ext cx="1691640" cy="685800"/>
+          </a:xfrm>
+          <a:prstGeom prst="rect">
+            <a:avLst/>
+          </a:prstGeom>
+          <a:noFill/>
+          <a:ln/>
+        </p:spPr>
+        <p:txBody>
+          <a:bodyPr wrap="square" lIns="0" tIns="0" rIns="0" bIns="0" rtlCol="0" anchor="t"/>
+          <a:lstStyle/>
+          <a:p>
+            <a:pPr indent="0" marL="0">
+              <a:buNone/>
+            </a:pPr>
+            <a:r>
+              <a:rPr lang="en-US" sz="1700" b="1" dirty="0">
+                <a:solidFill>
+                  <a:srgbClr val="274289"/>
+                </a:solidFill>
+              </a:rPr>
+              <a:t>Evaluasi</a:t>
+            </a:r>
+            <a:endParaRPr lang="en-US" sz="1700" dirty="0"/>
+          </a:p>
+        </p:txBody>
+      </p:sp>
+      <p:sp>
+        <p:nvSpPr>
+          <p:cNvPr id="27" name="Text 25"/>
+          <p:cNvSpPr txBox="1"/>
+          <p:nvPr/>
+        </p:nvSpPr>
+        <p:spPr>
+          <a:xfrm>
+            <a:off x="7452360" y="3703320"/>
+            <a:ext cx="1691640" cy="1234440"/>
+          </a:xfrm>
+          <a:prstGeom prst="rect">
+            <a:avLst/>
+          </a:prstGeom>
+          <a:noFill/>
+          <a:ln/>
+        </p:spPr>
+        <p:txBody>
+          <a:bodyPr wrap="square" lIns="0" tIns="0" rIns="0" bIns="0" rtlCol="0" anchor="t"/>
+          <a:lstStyle/>
+          <a:p>
+            <a:pPr indent="0" marL="0">
+              <a:buNone/>
+            </a:pPr>
+            <a:r>
+              <a:rPr lang="en-US" sz="1250" dirty="0">
+                <a:solidFill>
+                  <a:srgbClr val="1B2437"/>
+                </a:solidFill>
+              </a:rPr>
+              <a:t>Laporan evaluasi kepada Direksi: penggunaan, stok, dan kecepatan persetujuan.</a:t>
+            </a:r>
+            <a:endParaRPr lang="en-US" sz="1250" dirty="0"/>
+          </a:p>
+        </p:txBody>
+      </p:sp>
+      <p:sp>
+        <p:nvSpPr>
+          <p:cNvPr id="28" name="Text 26"/>
+          <p:cNvSpPr txBox="1"/>
+          <p:nvPr/>
+        </p:nvSpPr>
+        <p:spPr>
+          <a:xfrm>
+            <a:off x="9464040" y="1691640"/>
+            <a:ext cx="2057400" cy="320040"/>
+          </a:xfrm>
+          <a:prstGeom prst="rect">
+            <a:avLst/>
+          </a:prstGeom>
+          <a:noFill/>
+          <a:ln/>
+        </p:spPr>
+        <p:txBody>
+          <a:bodyPr wrap="square" lIns="0" tIns="0" rIns="0" bIns="0" rtlCol="0" anchor="t"/>
+          <a:lstStyle/>
+          <a:p>
+            <a:pPr algn="ctr" indent="0" marL="0">
+              <a:buNone/>
+            </a:pPr>
+            <a:r>
+              <a:rPr lang="en-US" sz="1300" b="1" dirty="0">
+                <a:solidFill>
+                  <a:srgbClr val="5B6B86"/>
+                </a:solidFill>
+              </a:rPr>
+              <a:t>2027</a:t>
+            </a:r>
+            <a:endParaRPr lang="en-US" sz="1300" dirty="0"/>
+          </a:p>
+        </p:txBody>
+      </p:sp>
+      <p:sp>
+        <p:nvSpPr>
+          <p:cNvPr id="29" name="Titik Pengembangan lanjutan"/>
+          <p:cNvSpPr/>
+          <p:nvPr/>
+        </p:nvSpPr>
+        <p:spPr>
+          <a:xfrm>
+            <a:off x="10328148" y="2167128"/>
+            <a:ext cx="329184" cy="329184"/>
+          </a:xfrm>
+          <a:prstGeom prst="ellipse">
+            <a:avLst/>
+          </a:prstGeom>
+          <a:solidFill>
+            <a:srgbClr val="274289"/>
+          </a:solidFill>
+          <a:ln w="31750">
+            <a:solidFill>
+              <a:srgbClr val="FFFFFF"/>
+            </a:solidFill>
+            <a:prstDash val="solid"/>
+          </a:ln>
+        </p:spPr>
+      </p:sp>
+      <p:sp>
+        <p:nvSpPr>
+          <p:cNvPr id="30" name="Fase Pengembangan lanjutan"/>
+          <p:cNvSpPr/>
+          <p:nvPr/>
+        </p:nvSpPr>
+        <p:spPr>
+          <a:xfrm>
+            <a:off x="9464040" y="2697480"/>
+            <a:ext cx="2057400" cy="2331720"/>
+          </a:xfrm>
+          <a:prstGeom prst="roundRect">
+            <a:avLst>
+              <a:gd name="adj" fmla="val 5333"/>
+            </a:avLst>
+          </a:prstGeom>
+          <a:solidFill>
+            <a:srgbClr val="EEF3FA"/>
+          </a:solidFill>
+          <a:ln w="9525">
+            <a:solidFill>
+              <a:srgbClr val="EEF3FA"/>
+            </a:solidFill>
+            <a:prstDash val="solid"/>
+          </a:ln>
+          <a:effectLst>
+            <a:outerShdw sx="100000" sy="100000" kx="0" ky="0" algn="bl" rotWithShape="0" blurRad="101600" dist="25400" dir="5400000">
+              <a:srgbClr val="274289">
+                <a:alpha val="12000"/>
+              </a:srgbClr>
+            </a:outerShdw>
+          </a:effectLst>
+        </p:spPr>
+      </p:sp>
+      <p:sp>
+        <p:nvSpPr>
+          <p:cNvPr id="31" name="Aksen"/>
+          <p:cNvSpPr/>
+          <p:nvPr/>
+        </p:nvSpPr>
+        <p:spPr>
+          <a:xfrm>
+            <a:off x="9646920" y="2880360"/>
+            <a:ext cx="411480" cy="54864"/>
+          </a:xfrm>
+          <a:prstGeom prst="rect">
+            <a:avLst/>
+          </a:prstGeom>
+          <a:solidFill>
+            <a:srgbClr val="5AB4E5"/>
+          </a:solidFill>
+          <a:ln w="12700">
+            <a:solidFill>
+              <a:srgbClr val="5AB4E5"/>
+            </a:solidFill>
+            <a:prstDash val="solid"/>
+          </a:ln>
+        </p:spPr>
+      </p:sp>
+      <p:sp>
+        <p:nvSpPr>
+          <p:cNvPr id="32" name="Text 30"/>
+          <p:cNvSpPr txBox="1"/>
+          <p:nvPr/>
+        </p:nvSpPr>
+        <p:spPr>
+          <a:xfrm>
+            <a:off x="9646920" y="3017520"/>
+            <a:ext cx="1691640" cy="685800"/>
+          </a:xfrm>
+          <a:prstGeom prst="rect">
+            <a:avLst/>
+          </a:prstGeom>
+          <a:noFill/>
+          <a:ln/>
+        </p:spPr>
+        <p:txBody>
+          <a:bodyPr wrap="square" lIns="0" tIns="0" rIns="0" bIns="0" rtlCol="0" anchor="t"/>
+          <a:lstStyle/>
+          <a:p>
+            <a:pPr indent="0" marL="0">
+              <a:buNone/>
+            </a:pPr>
+            <a:r>
+              <a:rPr lang="en-US" sz="1700" b="1" dirty="0">
+                <a:solidFill>
+                  <a:srgbClr val="274289"/>
+                </a:solidFill>
+              </a:rPr>
+              <a:t>Pengembangan lanjutan</a:t>
+            </a:r>
+            <a:endParaRPr lang="en-US" sz="1700" dirty="0"/>
+          </a:p>
+        </p:txBody>
+      </p:sp>
+      <p:sp>
+        <p:nvSpPr>
+          <p:cNvPr id="33" name="Text 31"/>
+          <p:cNvSpPr txBox="1"/>
+          <p:nvPr/>
+        </p:nvSpPr>
+        <p:spPr>
+          <a:xfrm>
+            <a:off x="9646920" y="3703320"/>
+            <a:ext cx="1691640" cy="1234440"/>
+          </a:xfrm>
+          <a:prstGeom prst="rect">
+            <a:avLst/>
+          </a:prstGeom>
+          <a:noFill/>
+          <a:ln/>
+        </p:spPr>
+        <p:txBody>
+          <a:bodyPr wrap="square" lIns="0" tIns="0" rIns="0" bIns="0" rtlCol="0" anchor="t"/>
+          <a:lstStyle/>
+          <a:p>
+            <a:pPr indent="0" marL="0">
+              <a:buNone/>
+            </a:pPr>
+            <a:r>
+              <a:rPr lang="en-US" sz="1250" dirty="0">
+                <a:solidFill>
+                  <a:srgbClr val="1B2437"/>
+                </a:solidFill>
+              </a:rPr>
+              <a:t>Aktivasi retur dan kas keluar, serta kajian aplikasi kasir iOS.</a:t>
+            </a:r>
+            <a:endParaRPr lang="en-US" sz="1250" dirty="0"/>
+          </a:p>
+        </p:txBody>
+      </p:sp>
+      <p:sp>
+        <p:nvSpPr>
+          <p:cNvPr id="34" name="Text 32"/>
+          <p:cNvSpPr txBox="1"/>
+          <p:nvPr/>
+        </p:nvSpPr>
+        <p:spPr>
+          <a:xfrm>
+            <a:off x="1600200" y="5257800"/>
+            <a:ext cx="9921240" cy="320040"/>
+          </a:xfrm>
+          <a:prstGeom prst="rect">
+            <a:avLst/>
+          </a:prstGeom>
+          <a:noFill/>
+          <a:ln/>
+        </p:spPr>
+        <p:txBody>
+          <a:bodyPr wrap="square" lIns="0" tIns="0" rIns="0" bIns="0" rtlCol="0" anchor="t"/>
+          <a:lstStyle/>
+          <a:p>
+            <a:pPr indent="0" marL="0">
+              <a:buNone/>
+            </a:pPr>
+            <a:r>
+              <a:rPr lang="en-US" sz="1200" i="1" dirty="0">
+                <a:solidFill>
+                  <a:srgbClr val="5B6B86"/>
+                </a:solidFill>
+              </a:rPr>
+              <a:t>Jadwal di atas adalah usulan dan dapat disesuaikan dengan keputusan Direksi.</a:t>
+            </a:r>
+            <a:endParaRPr lang="en-US" sz="1200" dirty="0"/>
+          </a:p>
+        </p:txBody>
+      </p:sp>
+      <p:sp>
+        <p:nvSpPr>
+          <p:cNvPr id="25" name="Slide Number Placeholder 0"/>
+          <p:cNvSpPr>
+            <a:spLocks noGrp="1"/>
+          </p:cNvSpPr>
+          <p:nvPr>
+            <p:ph type="sldNum" sz="quarter" idx="4294967295"/>
+          </p:nvPr>
+        </p:nvSpPr>
+        <p:spPr>
+          <a:xfrm>
+            <a:off x="11109960" y="6309360"/>
+            <a:ext cx="457200" cy="274320"/>
+          </a:xfrm>
+          <a:prstGeom prst="rect">
+            <a:avLst/>
+          </a:prstGeom>
+          <a:extLst>
+            <a:ext uri="{C572A759-6A51-4108-AA02-DFA0A04FC94B}">
+              <ma14:wrappingTextBoxFlag xmlns:ma14="http://schemas.microsoft.com/office/mac/drawingml/2011/main" val="0"/>
+            </a:ext>
+          </a:extLst>
+        </p:spPr>
+        <p:txBody>
+          <a:bodyPr/>
+          <a:lstStyle>
+            <a:lvl1pPr>
+              <a:defRPr sz="1000">
+                <a:solidFill>
+                  <a:srgbClr val="5B6B86"/>
+                </a:solidFill>
+              </a:defRPr>
+            </a:lvl1pPr>
+          </a:lstStyle>
+          <a:p>
+            <a:pPr algn="r"/>
+            <a:fld id="{F7021451-1387-4CA6-816F-3879F97B5CBC}" type="slidenum">
+              <a:rPr b="0" lang="en-US"/>
+              <a:t>9</a:t>
+            </a:fld>
+            <a:endParaRPr lang="en-US"/>
           </a:p>
         </p:txBody>
       </p:sp>

</xml_diff>